<commit_message>
Replace PDFs with Microsoft Word/PowerPoint exports and re-save deck in PowerPoint
Co-Authored-By: Claude Opus 5.5 <noreply@anthropic.com>
</commit_message>
<xml_diff>
--- a/slides/Scalable_Bayesian_Volatility.pptx
+++ b/slides/Scalable_Bayesian_Volatility.pptx
@@ -5,27 +5,27 @@
     <p:sldMasterId id="2147483648" r:id="rId1"/>
   </p:sldMasterIdLst>
   <p:notesMasterIdLst>
-    <p:notesMasterId r:id="rId15"/>
+    <p:notesMasterId r:id="rId20"/>
   </p:notesMasterIdLst>
   <p:sldIdLst>
     <p:sldId id="256" r:id="rId2"/>
-    <p:sldId id="290" r:id="rId24"/>
-    <p:sldId id="257" r:id="rId3"/>
-    <p:sldId id="269" r:id="rId4"/>
-    <p:sldId id="259" r:id="rId5"/>
-    <p:sldId id="278" r:id="rId20"/>
-    <p:sldId id="273" r:id="rId7"/>
-    <p:sldId id="279" r:id="rId13"/>
-    <p:sldId id="280" r:id="rId14"/>
-    <p:sldId id="281" r:id="rId12"/>
-    <p:sldId id="282" r:id="rId11"/>
-    <p:sldId id="283" r:id="rId10"/>
-    <p:sldId id="284" r:id="rId9"/>
-    <p:sldId id="285" r:id="rId8"/>
-    <p:sldId id="286" r:id="rId6"/>
-    <p:sldId id="287" r:id="rId21"/>
-    <p:sldId id="288" r:id="rId22"/>
-    <p:sldId id="289" r:id="rId23"/>
+    <p:sldId id="290" r:id="rId3"/>
+    <p:sldId id="257" r:id="rId4"/>
+    <p:sldId id="269" r:id="rId5"/>
+    <p:sldId id="259" r:id="rId6"/>
+    <p:sldId id="278" r:id="rId7"/>
+    <p:sldId id="273" r:id="rId8"/>
+    <p:sldId id="279" r:id="rId9"/>
+    <p:sldId id="280" r:id="rId10"/>
+    <p:sldId id="281" r:id="rId11"/>
+    <p:sldId id="282" r:id="rId12"/>
+    <p:sldId id="283" r:id="rId13"/>
+    <p:sldId id="284" r:id="rId14"/>
+    <p:sldId id="285" r:id="rId15"/>
+    <p:sldId id="286" r:id="rId16"/>
+    <p:sldId id="287" r:id="rId17"/>
+    <p:sldId id="288" r:id="rId18"/>
+    <p:sldId id="289" r:id="rId19"/>
   </p:sldIdLst>
   <p:sldSz cx="16256000" cy="9144000"/>
   <p:notesSz cx="6858000" cy="9144000"/>
@@ -225,7 +225,7 @@
           <a:p>
             <a:fld id="{583FA3D5-BD31-954D-B07C-0CE908957AF9}" type="datetimeFigureOut">
               <a:rPr lang="en-US" smtClean="0"/>
-              <a:t>5/4/26</a:t>
+              <a:t>10/23/26</a:t>
             </a:fld>
             <a:endParaRPr lang="en-US"/>
           </a:p>
@@ -1042,7 +1042,7 @@
           <a:p>
             <a:fld id="{C7C5836E-7A3E-3E4F-97CD-9521615F10CA}" type="slidenum">
               <a:rPr lang="en-US" smtClean="0"/>
-              <a:t>2</a:t>
+              <a:t>3</a:t>
             </a:fld>
             <a:endParaRPr lang="en-US"/>
           </a:p>
@@ -1529,7 +1529,7 @@
           <a:p>
             <a:fld id="{C7C5836E-7A3E-3E4F-97CD-9521615F10CA}" type="slidenum">
               <a:rPr lang="en-US" smtClean="0"/>
-              <a:t>3</a:t>
+              <a:t>4</a:t>
             </a:fld>
             <a:endParaRPr lang="en-US"/>
           </a:p>
@@ -1831,7 +1831,7 @@
           <a:p>
             <a:fld id="{C7C5836E-7A3E-3E4F-97CD-9521615F10CA}" type="slidenum">
               <a:rPr lang="en-US" smtClean="0"/>
-              <a:t>4</a:t>
+              <a:t>5</a:t>
             </a:fld>
             <a:endParaRPr lang="en-US"/>
           </a:p>
@@ -1850,7 +1850,7 @@
 </p:notes>
 </file>
 
-<file path=ppt/notesSlides/notesSlide6.xml><?xml version="1.0" encoding="utf-8"?>
+<file path=ppt/notesSlides/notesSlide5.xml><?xml version="1.0" encoding="utf-8"?>
 <p:notes xmlns:a="http://schemas.openxmlformats.org/drawingml/2006/main" xmlns:r="http://schemas.openxmlformats.org/officeDocument/2006/relationships" xmlns:p="http://schemas.openxmlformats.org/presentationml/2006/main">
   <p:cSld>
     <p:spTree>
@@ -2381,7 +2381,7 @@
           <a:p>
             <a:fld id="{C7C5836E-7A3E-3E4F-97CD-9521615F10CA}" type="slidenum">
               <a:rPr lang="en-US" smtClean="0"/>
-              <a:t>6</a:t>
+              <a:t>7</a:t>
             </a:fld>
             <a:endParaRPr lang="en-US"/>
           </a:p>
@@ -2580,7 +2580,7 @@
             <a:fld id="{1D8BD707-D9CF-40AE-B4C6-C98DA3205C09}" type="datetimeFigureOut">
               <a:rPr lang="en-US" smtClean="0"/>
               <a:pPr/>
-              <a:t>5/4/26</a:t>
+              <a:t>10/23/26</a:t>
             </a:fld>
             <a:endParaRPr lang="en-US"/>
           </a:p>
@@ -2745,7 +2745,7 @@
             <a:fld id="{1D8BD707-D9CF-40AE-B4C6-C98DA3205C09}" type="datetimeFigureOut">
               <a:rPr lang="en-US" smtClean="0"/>
               <a:pPr/>
-              <a:t>5/4/26</a:t>
+              <a:t>10/23/26</a:t>
             </a:fld>
             <a:endParaRPr lang="en-US"/>
           </a:p>
@@ -2920,7 +2920,7 @@
             <a:fld id="{1D8BD707-D9CF-40AE-B4C6-C98DA3205C09}" type="datetimeFigureOut">
               <a:rPr lang="en-US" smtClean="0"/>
               <a:pPr/>
-              <a:t>5/4/26</a:t>
+              <a:t>10/23/26</a:t>
             </a:fld>
             <a:endParaRPr lang="en-US"/>
           </a:p>
@@ -3085,7 +3085,7 @@
             <a:fld id="{1D8BD707-D9CF-40AE-B4C6-C98DA3205C09}" type="datetimeFigureOut">
               <a:rPr lang="en-US" smtClean="0"/>
               <a:pPr/>
-              <a:t>5/4/26</a:t>
+              <a:t>10/23/26</a:t>
             </a:fld>
             <a:endParaRPr lang="en-US"/>
           </a:p>
@@ -3327,7 +3327,7 @@
             <a:fld id="{1D8BD707-D9CF-40AE-B4C6-C98DA3205C09}" type="datetimeFigureOut">
               <a:rPr lang="en-US" smtClean="0"/>
               <a:pPr/>
-              <a:t>5/4/26</a:t>
+              <a:t>10/23/26</a:t>
             </a:fld>
             <a:endParaRPr lang="en-US"/>
           </a:p>
@@ -3609,7 +3609,7 @@
             <a:fld id="{1D8BD707-D9CF-40AE-B4C6-C98DA3205C09}" type="datetimeFigureOut">
               <a:rPr lang="en-US" smtClean="0"/>
               <a:pPr/>
-              <a:t>5/4/26</a:t>
+              <a:t>10/23/26</a:t>
             </a:fld>
             <a:endParaRPr lang="en-US"/>
           </a:p>
@@ -4025,7 +4025,7 @@
             <a:fld id="{1D8BD707-D9CF-40AE-B4C6-C98DA3205C09}" type="datetimeFigureOut">
               <a:rPr lang="en-US" smtClean="0"/>
               <a:pPr/>
-              <a:t>5/4/26</a:t>
+              <a:t>10/23/26</a:t>
             </a:fld>
             <a:endParaRPr lang="en-US"/>
           </a:p>
@@ -4139,7 +4139,7 @@
             <a:fld id="{1D8BD707-D9CF-40AE-B4C6-C98DA3205C09}" type="datetimeFigureOut">
               <a:rPr lang="en-US" smtClean="0"/>
               <a:pPr/>
-              <a:t>5/4/26</a:t>
+              <a:t>10/23/26</a:t>
             </a:fld>
             <a:endParaRPr lang="en-US"/>
           </a:p>
@@ -4231,7 +4231,7 @@
             <a:fld id="{1D8BD707-D9CF-40AE-B4C6-C98DA3205C09}" type="datetimeFigureOut">
               <a:rPr lang="en-US" smtClean="0"/>
               <a:pPr/>
-              <a:t>5/4/26</a:t>
+              <a:t>10/23/26</a:t>
             </a:fld>
             <a:endParaRPr lang="en-US"/>
           </a:p>
@@ -4503,7 +4503,7 @@
             <a:fld id="{1D8BD707-D9CF-40AE-B4C6-C98DA3205C09}" type="datetimeFigureOut">
               <a:rPr lang="en-US" smtClean="0"/>
               <a:pPr/>
-              <a:t>5/4/26</a:t>
+              <a:t>10/23/26</a:t>
             </a:fld>
             <a:endParaRPr lang="en-US"/>
           </a:p>
@@ -4752,7 +4752,7 @@
             <a:fld id="{1D8BD707-D9CF-40AE-B4C6-C98DA3205C09}" type="datetimeFigureOut">
               <a:rPr lang="en-US" smtClean="0"/>
               <a:pPr/>
-              <a:t>5/4/26</a:t>
+              <a:t>10/23/26</a:t>
             </a:fld>
             <a:endParaRPr lang="en-US"/>
           </a:p>
@@ -4960,7 +4960,7 @@
             <a:fld id="{1D8BD707-D9CF-40AE-B4C6-C98DA3205C09}" type="datetimeFigureOut">
               <a:rPr lang="en-US" smtClean="0"/>
               <a:pPr/>
-              <a:t>5/4/26</a:t>
+              <a:t>10/23/26</a:t>
             </a:fld>
             <a:endParaRPr lang="en-US"/>
           </a:p>
@@ -5704,7 +5704,7 @@
 </file>
 
 <file path=ppt/slides/slide10.xml><?xml version="1.0" encoding="utf-8"?>
-<p:sld xmlns:a="http://schemas.openxmlformats.org/drawingml/2006/main" xmlns:p="http://schemas.openxmlformats.org/presentationml/2006/main" xmlns:r="http://schemas.openxmlformats.org/officeDocument/2006/relationships">
+<p:sld xmlns:a="http://schemas.openxmlformats.org/drawingml/2006/main" xmlns:r="http://schemas.openxmlformats.org/officeDocument/2006/relationships" xmlns:p="http://schemas.openxmlformats.org/presentationml/2006/main">
   <p:cSld>
     <p:spTree>
       <p:nvGrpSpPr>
@@ -5712,7 +5712,14 @@
         <p:cNvGrpSpPr/>
         <p:nvPr/>
       </p:nvGrpSpPr>
-      <p:grpSpPr/>
+      <p:grpSpPr>
+        <a:xfrm>
+          <a:off x="0" y="0"/>
+          <a:ext cx="0" cy="0"/>
+          <a:chOff x="0" y="0"/>
+          <a:chExt cx="0" cy="0"/>
+        </a:xfrm>
+      </p:grpSpPr>
       <p:sp>
         <p:nvSpPr>
           <p:cNvPr id="2" name="TextBox 1"/>
@@ -5730,7 +5737,7 @@
           <a:noFill/>
         </p:spPr>
         <p:txBody>
-          <a:bodyPr wrap="square" anchor="ctr" lIns="73152" rIns="73152" tIns="73152" bIns="73152">
+          <a:bodyPr wrap="square" lIns="73152" tIns="73152" rIns="73152" bIns="73152" anchor="ctr">
             <a:spAutoFit/>
           </a:bodyPr>
           <a:lstStyle/>
@@ -5766,13 +5773,55 @@
                 <a:tableStyleId>{5C22544A-7EE6-4342-B048-85BDC9FD1C3A}</a:tableStyleId>
               </a:tblPr>
               <a:tblGrid>
-                <a:gridCol w="2834640"/>
-                <a:gridCol w="2057400"/>
-                <a:gridCol w="2057400"/>
-                <a:gridCol w="2057400"/>
-                <a:gridCol w="2057400"/>
-                <a:gridCol w="2057400"/>
-                <a:gridCol w="2057400"/>
+                <a:gridCol w="2834640">
+                  <a:extLst>
+                    <a:ext uri="{9D8B030D-6E8A-4147-A177-3AD203B41FA5}">
+                      <a16:colId xmlns:a16="http://schemas.microsoft.com/office/drawing/2014/main" val="20000"/>
+                    </a:ext>
+                  </a:extLst>
+                </a:gridCol>
+                <a:gridCol w="2057400">
+                  <a:extLst>
+                    <a:ext uri="{9D8B030D-6E8A-4147-A177-3AD203B41FA5}">
+                      <a16:colId xmlns:a16="http://schemas.microsoft.com/office/drawing/2014/main" val="20001"/>
+                    </a:ext>
+                  </a:extLst>
+                </a:gridCol>
+                <a:gridCol w="2057400">
+                  <a:extLst>
+                    <a:ext uri="{9D8B030D-6E8A-4147-A177-3AD203B41FA5}">
+                      <a16:colId xmlns:a16="http://schemas.microsoft.com/office/drawing/2014/main" val="20002"/>
+                    </a:ext>
+                  </a:extLst>
+                </a:gridCol>
+                <a:gridCol w="2057400">
+                  <a:extLst>
+                    <a:ext uri="{9D8B030D-6E8A-4147-A177-3AD203B41FA5}">
+                      <a16:colId xmlns:a16="http://schemas.microsoft.com/office/drawing/2014/main" val="20003"/>
+                    </a:ext>
+                  </a:extLst>
+                </a:gridCol>
+                <a:gridCol w="2057400">
+                  <a:extLst>
+                    <a:ext uri="{9D8B030D-6E8A-4147-A177-3AD203B41FA5}">
+                      <a16:colId xmlns:a16="http://schemas.microsoft.com/office/drawing/2014/main" val="20004"/>
+                    </a:ext>
+                  </a:extLst>
+                </a:gridCol>
+                <a:gridCol w="2057400">
+                  <a:extLst>
+                    <a:ext uri="{9D8B030D-6E8A-4147-A177-3AD203B41FA5}">
+                      <a16:colId xmlns:a16="http://schemas.microsoft.com/office/drawing/2014/main" val="20005"/>
+                    </a:ext>
+                  </a:extLst>
+                </a:gridCol>
+                <a:gridCol w="2057400">
+                  <a:extLst>
+                    <a:ext uri="{9D8B030D-6E8A-4147-A177-3AD203B41FA5}">
+                      <a16:colId xmlns:a16="http://schemas.microsoft.com/office/drawing/2014/main" val="20006"/>
+                    </a:ext>
+                  </a:extLst>
+                </a:gridCol>
               </a:tblGrid>
               <a:tr h="658368">
                 <a:tc>
@@ -5791,7 +5840,7 @@
                       </a:r>
                     </a:p>
                   </a:txBody>
-                  <a:tcPr anchor="ctr" marL="73152" marR="73152">
+                  <a:tcPr marL="73152" marR="73152" anchor="ctr">
                     <a:solidFill>
                       <a:srgbClr val="2A6F8A"/>
                     </a:solidFill>
@@ -5813,7 +5862,7 @@
                       </a:r>
                     </a:p>
                   </a:txBody>
-                  <a:tcPr anchor="ctr" marL="73152" marR="73152">
+                  <a:tcPr marL="73152" marR="73152" anchor="ctr">
                     <a:solidFill>
                       <a:srgbClr val="2A6F8A"/>
                     </a:solidFill>
@@ -5835,7 +5884,7 @@
                       </a:r>
                     </a:p>
                   </a:txBody>
-                  <a:tcPr anchor="ctr" marL="73152" marR="73152">
+                  <a:tcPr marL="73152" marR="73152" anchor="ctr">
                     <a:solidFill>
                       <a:srgbClr val="2A6F8A"/>
                     </a:solidFill>
@@ -5857,7 +5906,7 @@
                       </a:r>
                     </a:p>
                   </a:txBody>
-                  <a:tcPr anchor="ctr" marL="73152" marR="73152">
+                  <a:tcPr marL="73152" marR="73152" anchor="ctr">
                     <a:solidFill>
                       <a:srgbClr val="2A6F8A"/>
                     </a:solidFill>
@@ -5879,7 +5928,7 @@
                       </a:r>
                     </a:p>
                   </a:txBody>
-                  <a:tcPr anchor="ctr" marL="73152" marR="73152">
+                  <a:tcPr marL="73152" marR="73152" anchor="ctr">
                     <a:solidFill>
                       <a:srgbClr val="D08F27"/>
                     </a:solidFill>
@@ -5901,7 +5950,7 @@
                       </a:r>
                     </a:p>
                   </a:txBody>
-                  <a:tcPr anchor="ctr" marL="73152" marR="73152">
+                  <a:tcPr marL="73152" marR="73152" anchor="ctr">
                     <a:solidFill>
                       <a:srgbClr val="D08F27"/>
                     </a:solidFill>
@@ -5923,12 +5972,17 @@
                       </a:r>
                     </a:p>
                   </a:txBody>
-                  <a:tcPr anchor="ctr" marL="73152" marR="73152">
+                  <a:tcPr marL="73152" marR="73152" anchor="ctr">
                     <a:solidFill>
                       <a:srgbClr val="D08F27"/>
                     </a:solidFill>
                   </a:tcPr>
                 </a:tc>
+                <a:extLst>
+                  <a:ext uri="{0D108BD9-81ED-4DB2-BD59-A6C34878D82A}">
+                    <a16:rowId xmlns:a16="http://schemas.microsoft.com/office/drawing/2014/main" val="10000"/>
+                  </a:ext>
+                </a:extLst>
               </a:tr>
               <a:tr h="658368">
                 <a:tc>
@@ -5947,7 +6001,7 @@
                       </a:r>
                     </a:p>
                   </a:txBody>
-                  <a:tcPr anchor="ctr" marL="73152" marR="73152">
+                  <a:tcPr marL="73152" marR="73152" anchor="ctr">
                     <a:solidFill>
                       <a:srgbClr val="FFFFFF"/>
                     </a:solidFill>
@@ -5969,7 +6023,7 @@
                       </a:r>
                     </a:p>
                   </a:txBody>
-                  <a:tcPr anchor="ctr" marL="73152" marR="73152">
+                  <a:tcPr marL="73152" marR="73152" anchor="ctr">
                     <a:solidFill>
                       <a:srgbClr val="FFFFFF"/>
                     </a:solidFill>
@@ -5991,7 +6045,7 @@
                       </a:r>
                     </a:p>
                   </a:txBody>
-                  <a:tcPr anchor="ctr" marL="73152" marR="73152">
+                  <a:tcPr marL="73152" marR="73152" anchor="ctr">
                     <a:solidFill>
                       <a:srgbClr val="FFFFFF"/>
                     </a:solidFill>
@@ -6013,7 +6067,7 @@
                       </a:r>
                     </a:p>
                   </a:txBody>
-                  <a:tcPr anchor="ctr" marL="73152" marR="73152">
+                  <a:tcPr marL="73152" marR="73152" anchor="ctr">
                     <a:solidFill>
                       <a:srgbClr val="FFFFFF"/>
                     </a:solidFill>
@@ -6035,7 +6089,7 @@
                       </a:r>
                     </a:p>
                   </a:txBody>
-                  <a:tcPr anchor="ctr" marL="73152" marR="73152">
+                  <a:tcPr marL="73152" marR="73152" anchor="ctr">
                     <a:solidFill>
                       <a:srgbClr val="FBF4E8"/>
                     </a:solidFill>
@@ -6057,7 +6111,7 @@
                       </a:r>
                     </a:p>
                   </a:txBody>
-                  <a:tcPr anchor="ctr" marL="73152" marR="73152">
+                  <a:tcPr marL="73152" marR="73152" anchor="ctr">
                     <a:solidFill>
                       <a:srgbClr val="FBF4E8"/>
                     </a:solidFill>
@@ -6079,12 +6133,17 @@
                       </a:r>
                     </a:p>
                   </a:txBody>
-                  <a:tcPr anchor="ctr" marL="73152" marR="73152">
+                  <a:tcPr marL="73152" marR="73152" anchor="ctr">
                     <a:solidFill>
                       <a:srgbClr val="FBF4E8"/>
                     </a:solidFill>
                   </a:tcPr>
                 </a:tc>
+                <a:extLst>
+                  <a:ext uri="{0D108BD9-81ED-4DB2-BD59-A6C34878D82A}">
+                    <a16:rowId xmlns:a16="http://schemas.microsoft.com/office/drawing/2014/main" val="10001"/>
+                  </a:ext>
+                </a:extLst>
               </a:tr>
               <a:tr h="658368">
                 <a:tc>
@@ -6103,7 +6162,7 @@
                       </a:r>
                     </a:p>
                   </a:txBody>
-                  <a:tcPr anchor="ctr" marL="73152" marR="73152">
+                  <a:tcPr marL="73152" marR="73152" anchor="ctr">
                     <a:solidFill>
                       <a:srgbClr val="F2F2F2"/>
                     </a:solidFill>
@@ -6125,7 +6184,7 @@
                       </a:r>
                     </a:p>
                   </a:txBody>
-                  <a:tcPr anchor="ctr" marL="73152" marR="73152">
+                  <a:tcPr marL="73152" marR="73152" anchor="ctr">
                     <a:solidFill>
                       <a:srgbClr val="F2F2F2"/>
                     </a:solidFill>
@@ -6147,7 +6206,7 @@
                       </a:r>
                     </a:p>
                   </a:txBody>
-                  <a:tcPr anchor="ctr" marL="73152" marR="73152">
+                  <a:tcPr marL="73152" marR="73152" anchor="ctr">
                     <a:solidFill>
                       <a:srgbClr val="F2F2F2"/>
                     </a:solidFill>
@@ -6169,7 +6228,7 @@
                       </a:r>
                     </a:p>
                   </a:txBody>
-                  <a:tcPr anchor="ctr" marL="73152" marR="73152">
+                  <a:tcPr marL="73152" marR="73152" anchor="ctr">
                     <a:solidFill>
                       <a:srgbClr val="F2F2F2"/>
                     </a:solidFill>
@@ -6191,7 +6250,7 @@
                       </a:r>
                     </a:p>
                   </a:txBody>
-                  <a:tcPr anchor="ctr" marL="73152" marR="73152">
+                  <a:tcPr marL="73152" marR="73152" anchor="ctr">
                     <a:solidFill>
                       <a:srgbClr val="FBF4E8"/>
                     </a:solidFill>
@@ -6213,7 +6272,7 @@
                       </a:r>
                     </a:p>
                   </a:txBody>
-                  <a:tcPr anchor="ctr" marL="73152" marR="73152">
+                  <a:tcPr marL="73152" marR="73152" anchor="ctr">
                     <a:solidFill>
                       <a:srgbClr val="FBF4E8"/>
                     </a:solidFill>
@@ -6235,12 +6294,17 @@
                       </a:r>
                     </a:p>
                   </a:txBody>
-                  <a:tcPr anchor="ctr" marL="73152" marR="73152">
+                  <a:tcPr marL="73152" marR="73152" anchor="ctr">
                     <a:solidFill>
                       <a:srgbClr val="FBF4E8"/>
                     </a:solidFill>
                   </a:tcPr>
                 </a:tc>
+                <a:extLst>
+                  <a:ext uri="{0D108BD9-81ED-4DB2-BD59-A6C34878D82A}">
+                    <a16:rowId xmlns:a16="http://schemas.microsoft.com/office/drawing/2014/main" val="10002"/>
+                  </a:ext>
+                </a:extLst>
               </a:tr>
               <a:tr h="658368">
                 <a:tc>
@@ -6259,7 +6323,7 @@
                       </a:r>
                     </a:p>
                   </a:txBody>
-                  <a:tcPr anchor="ctr" marL="73152" marR="73152">
+                  <a:tcPr marL="73152" marR="73152" anchor="ctr">
                     <a:solidFill>
                       <a:srgbClr val="FFFFFF"/>
                     </a:solidFill>
@@ -6281,7 +6345,7 @@
                       </a:r>
                     </a:p>
                   </a:txBody>
-                  <a:tcPr anchor="ctr" marL="73152" marR="73152">
+                  <a:tcPr marL="73152" marR="73152" anchor="ctr">
                     <a:solidFill>
                       <a:srgbClr val="FFFFFF"/>
                     </a:solidFill>
@@ -6303,7 +6367,7 @@
                       </a:r>
                     </a:p>
                   </a:txBody>
-                  <a:tcPr anchor="ctr" marL="73152" marR="73152">
+                  <a:tcPr marL="73152" marR="73152" anchor="ctr">
                     <a:solidFill>
                       <a:srgbClr val="FFFFFF"/>
                     </a:solidFill>
@@ -6325,7 +6389,7 @@
                       </a:r>
                     </a:p>
                   </a:txBody>
-                  <a:tcPr anchor="ctr" marL="73152" marR="73152">
+                  <a:tcPr marL="73152" marR="73152" anchor="ctr">
                     <a:solidFill>
                       <a:srgbClr val="FFFFFF"/>
                     </a:solidFill>
@@ -6347,7 +6411,7 @@
                       </a:r>
                     </a:p>
                   </a:txBody>
-                  <a:tcPr anchor="ctr" marL="73152" marR="73152">
+                  <a:tcPr marL="73152" marR="73152" anchor="ctr">
                     <a:solidFill>
                       <a:srgbClr val="FBF4E8"/>
                     </a:solidFill>
@@ -6369,7 +6433,7 @@
                       </a:r>
                     </a:p>
                   </a:txBody>
-                  <a:tcPr anchor="ctr" marL="73152" marR="73152">
+                  <a:tcPr marL="73152" marR="73152" anchor="ctr">
                     <a:solidFill>
                       <a:srgbClr val="FBF4E8"/>
                     </a:solidFill>
@@ -6391,12 +6455,17 @@
                       </a:r>
                     </a:p>
                   </a:txBody>
-                  <a:tcPr anchor="ctr" marL="73152" marR="73152">
+                  <a:tcPr marL="73152" marR="73152" anchor="ctr">
                     <a:solidFill>
                       <a:srgbClr val="FBF4E8"/>
                     </a:solidFill>
                   </a:tcPr>
                 </a:tc>
+                <a:extLst>
+                  <a:ext uri="{0D108BD9-81ED-4DB2-BD59-A6C34878D82A}">
+                    <a16:rowId xmlns:a16="http://schemas.microsoft.com/office/drawing/2014/main" val="10003"/>
+                  </a:ext>
+                </a:extLst>
               </a:tr>
               <a:tr h="658368">
                 <a:tc>
@@ -6415,7 +6484,7 @@
                       </a:r>
                     </a:p>
                   </a:txBody>
-                  <a:tcPr anchor="ctr" marL="73152" marR="73152">
+                  <a:tcPr marL="73152" marR="73152" anchor="ctr">
                     <a:solidFill>
                       <a:srgbClr val="F2F2F2"/>
                     </a:solidFill>
@@ -6437,7 +6506,7 @@
                       </a:r>
                     </a:p>
                   </a:txBody>
-                  <a:tcPr anchor="ctr" marL="73152" marR="73152">
+                  <a:tcPr marL="73152" marR="73152" anchor="ctr">
                     <a:solidFill>
                       <a:srgbClr val="F2F2F2"/>
                     </a:solidFill>
@@ -6459,7 +6528,7 @@
                       </a:r>
                     </a:p>
                   </a:txBody>
-                  <a:tcPr anchor="ctr" marL="73152" marR="73152">
+                  <a:tcPr marL="73152" marR="73152" anchor="ctr">
                     <a:solidFill>
                       <a:srgbClr val="F2F2F2"/>
                     </a:solidFill>
@@ -6481,7 +6550,7 @@
                       </a:r>
                     </a:p>
                   </a:txBody>
-                  <a:tcPr anchor="ctr" marL="73152" marR="73152">
+                  <a:tcPr marL="73152" marR="73152" anchor="ctr">
                     <a:solidFill>
                       <a:srgbClr val="F2F2F2"/>
                     </a:solidFill>
@@ -6503,7 +6572,7 @@
                       </a:r>
                     </a:p>
                   </a:txBody>
-                  <a:tcPr anchor="ctr" marL="73152" marR="73152">
+                  <a:tcPr marL="73152" marR="73152" anchor="ctr">
                     <a:solidFill>
                       <a:srgbClr val="FBF4E8"/>
                     </a:solidFill>
@@ -6525,7 +6594,7 @@
                       </a:r>
                     </a:p>
                   </a:txBody>
-                  <a:tcPr anchor="ctr" marL="73152" marR="73152">
+                  <a:tcPr marL="73152" marR="73152" anchor="ctr">
                     <a:solidFill>
                       <a:srgbClr val="FBF4E8"/>
                     </a:solidFill>
@@ -6547,12 +6616,17 @@
                       </a:r>
                     </a:p>
                   </a:txBody>
-                  <a:tcPr anchor="ctr" marL="73152" marR="73152">
+                  <a:tcPr marL="73152" marR="73152" anchor="ctr">
                     <a:solidFill>
                       <a:srgbClr val="FBF4E8"/>
                     </a:solidFill>
                   </a:tcPr>
                 </a:tc>
+                <a:extLst>
+                  <a:ext uri="{0D108BD9-81ED-4DB2-BD59-A6C34878D82A}">
+                    <a16:rowId xmlns:a16="http://schemas.microsoft.com/office/drawing/2014/main" val="10004"/>
+                  </a:ext>
+                </a:extLst>
               </a:tr>
             </a:tbl>
           </a:graphicData>
@@ -6575,7 +6649,7 @@
           <a:noFill/>
         </p:spPr>
         <p:txBody>
-          <a:bodyPr wrap="square" anchor="t" lIns="73152" rIns="73152" tIns="73152" bIns="73152">
+          <a:bodyPr wrap="square" lIns="73152" tIns="73152" rIns="73152" bIns="73152" anchor="t">
             <a:spAutoFit/>
           </a:bodyPr>
           <a:lstStyle/>
@@ -6675,6 +6749,7 @@
           <a:lstStyle/>
           <a:p>
             <a:pPr algn="ctr"/>
+            <a:endParaRPr/>
           </a:p>
         </p:txBody>
       </p:sp>
@@ -6695,7 +6770,7 @@
           <a:noFill/>
         </p:spPr>
         <p:txBody>
-          <a:bodyPr wrap="square" anchor="t" lIns="73152" rIns="73152" tIns="73152" bIns="73152">
+          <a:bodyPr wrap="square" lIns="73152" tIns="73152" rIns="73152" bIns="73152" anchor="t">
             <a:spAutoFit/>
           </a:bodyPr>
           <a:lstStyle/>
@@ -6712,14 +6787,11 @@
           </a:p>
           <a:p>
             <a:pPr algn="ctr"/>
-            <a:r>
-              <a:rPr sz="2200" b="0">
-                <a:solidFill>
-                  <a:srgbClr val="000000"/>
-                </a:solidFill>
-              </a:rPr>
-              <a:t/>
-            </a:r>
+            <a:endParaRPr sz="2200" b="1">
+              <a:solidFill>
+                <a:srgbClr val="000000"/>
+              </a:solidFill>
+            </a:endParaRPr>
           </a:p>
           <a:p>
             <a:pPr algn="ctr"/>
@@ -6777,6 +6849,7 @@
           <a:lstStyle/>
           <a:p>
             <a:pPr algn="ctr"/>
+            <a:endParaRPr/>
           </a:p>
         </p:txBody>
       </p:sp>
@@ -6797,7 +6870,7 @@
           <a:noFill/>
         </p:spPr>
         <p:txBody>
-          <a:bodyPr wrap="square" anchor="t" lIns="73152" rIns="73152" tIns="73152" bIns="73152">
+          <a:bodyPr wrap="square" lIns="73152" tIns="73152" rIns="73152" bIns="73152" anchor="t">
             <a:spAutoFit/>
           </a:bodyPr>
           <a:lstStyle/>
@@ -6814,14 +6887,11 @@
           </a:p>
           <a:p>
             <a:pPr algn="ctr"/>
-            <a:r>
-              <a:rPr sz="2200" b="0">
-                <a:solidFill>
-                  <a:srgbClr val="000000"/>
-                </a:solidFill>
-              </a:rPr>
-              <a:t/>
-            </a:r>
+            <a:endParaRPr sz="2200" b="1">
+              <a:solidFill>
+                <a:srgbClr val="000000"/>
+              </a:solidFill>
+            </a:endParaRPr>
           </a:p>
           <a:p>
             <a:pPr algn="ctr"/>
@@ -6879,6 +6949,7 @@
           <a:lstStyle/>
           <a:p>
             <a:pPr algn="ctr"/>
+            <a:endParaRPr/>
           </a:p>
         </p:txBody>
       </p:sp>
@@ -6899,7 +6970,7 @@
           <a:noFill/>
         </p:spPr>
         <p:txBody>
-          <a:bodyPr wrap="square" anchor="t" lIns="73152" rIns="73152" tIns="73152" bIns="73152">
+          <a:bodyPr wrap="square" lIns="73152" tIns="73152" rIns="73152" bIns="73152" anchor="t">
             <a:spAutoFit/>
           </a:bodyPr>
           <a:lstStyle/>
@@ -6916,14 +6987,11 @@
           </a:p>
           <a:p>
             <a:pPr algn="ctr"/>
-            <a:r>
-              <a:rPr sz="2200" b="0">
-                <a:solidFill>
-                  <a:srgbClr val="000000"/>
-                </a:solidFill>
-              </a:rPr>
-              <a:t/>
-            </a:r>
+            <a:endParaRPr sz="2200" b="1">
+              <a:solidFill>
+                <a:srgbClr val="000000"/>
+              </a:solidFill>
+            </a:endParaRPr>
           </a:p>
           <a:p>
             <a:pPr algn="ctr"/>
@@ -6947,7 +7015,7 @@
 </file>
 
 <file path=ppt/slides/slide11.xml><?xml version="1.0" encoding="utf-8"?>
-<p:sld xmlns:a="http://schemas.openxmlformats.org/drawingml/2006/main" xmlns:p="http://schemas.openxmlformats.org/presentationml/2006/main" xmlns:r="http://schemas.openxmlformats.org/officeDocument/2006/relationships">
+<p:sld xmlns:a="http://schemas.openxmlformats.org/drawingml/2006/main" xmlns:r="http://schemas.openxmlformats.org/officeDocument/2006/relationships" xmlns:p="http://schemas.openxmlformats.org/presentationml/2006/main">
   <p:cSld>
     <p:spTree>
       <p:nvGrpSpPr>
@@ -6955,7 +7023,14 @@
         <p:cNvGrpSpPr/>
         <p:nvPr/>
       </p:nvGrpSpPr>
-      <p:grpSpPr/>
+      <p:grpSpPr>
+        <a:xfrm>
+          <a:off x="0" y="0"/>
+          <a:ext cx="0" cy="0"/>
+          <a:chOff x="0" y="0"/>
+          <a:chExt cx="0" cy="0"/>
+        </a:xfrm>
+      </p:grpSpPr>
       <p:sp>
         <p:nvSpPr>
           <p:cNvPr id="2" name="TextBox 1"/>
@@ -6973,7 +7048,7 @@
           <a:noFill/>
         </p:spPr>
         <p:txBody>
-          <a:bodyPr wrap="square" anchor="ctr" lIns="73152" rIns="73152" tIns="73152" bIns="73152">
+          <a:bodyPr wrap="square" lIns="73152" tIns="73152" rIns="73152" bIns="73152" anchor="ctr">
             <a:spAutoFit/>
           </a:bodyPr>
           <a:lstStyle/>
@@ -7213,6 +7288,7 @@
           <a:lstStyle/>
           <a:p>
             <a:pPr algn="ctr"/>
+            <a:endParaRPr/>
           </a:p>
         </p:txBody>
       </p:sp>
@@ -7233,14 +7309,14 @@
           <a:noFill/>
         </p:spPr>
         <p:txBody>
-          <a:bodyPr wrap="square" anchor="ctr" lIns="73152" rIns="73152" tIns="73152" bIns="73152">
+          <a:bodyPr wrap="square" lIns="73152" tIns="73152" rIns="73152" bIns="73152" anchor="ctr">
             <a:spAutoFit/>
           </a:bodyPr>
           <a:lstStyle/>
           <a:p>
             <a:pPr algn="ctr"/>
             <a:r>
-              <a:rPr sz="2000" b="0">
+              <a:rPr sz="2000" b="0" dirty="0">
                 <a:solidFill>
                   <a:srgbClr val="000000"/>
                 </a:solidFill>
@@ -7251,18 +7327,34 @@
           <a:p>
             <a:pPr algn="ctr"/>
             <a:r>
-              <a:rPr sz="2000" b="0">
+              <a:rPr sz="2000" b="0" dirty="0">
                 <a:solidFill>
                   <a:srgbClr val="000000"/>
                 </a:solidFill>
               </a:rPr>
-              <a:t>Full-cov VI: 0.050</a:t>
+              <a:t>Full-</a:t>
+            </a:r>
+            <a:r>
+              <a:rPr sz="2000" b="0" dirty="0" err="1">
+                <a:solidFill>
+                  <a:srgbClr val="000000"/>
+                </a:solidFill>
+              </a:rPr>
+              <a:t>cov</a:t>
+            </a:r>
+            <a:r>
+              <a:rPr sz="2000" b="0" dirty="0">
+                <a:solidFill>
+                  <a:srgbClr val="000000"/>
+                </a:solidFill>
+              </a:rPr>
+              <a:t> VI: 0.050</a:t>
             </a:r>
           </a:p>
           <a:p>
             <a:pPr algn="ctr"/>
             <a:r>
-              <a:rPr sz="2000" b="0">
+              <a:rPr sz="2000" b="0" dirty="0">
                 <a:solidFill>
                   <a:srgbClr val="000000"/>
                 </a:solidFill>
@@ -7315,6 +7407,7 @@
           <a:lstStyle/>
           <a:p>
             <a:pPr algn="ctr"/>
+            <a:endParaRPr/>
           </a:p>
         </p:txBody>
       </p:sp>
@@ -7335,14 +7428,14 @@
           <a:noFill/>
         </p:spPr>
         <p:txBody>
-          <a:bodyPr wrap="square" anchor="ctr" lIns="73152" rIns="73152" tIns="73152" bIns="73152">
+          <a:bodyPr wrap="square" lIns="73152" tIns="73152" rIns="73152" bIns="73152" anchor="ctr">
             <a:spAutoFit/>
           </a:bodyPr>
           <a:lstStyle/>
           <a:p>
             <a:pPr algn="ctr"/>
             <a:r>
-              <a:rPr sz="2000" b="0">
+              <a:rPr sz="2000" b="0" dirty="0">
                 <a:solidFill>
                   <a:srgbClr val="000000"/>
                 </a:solidFill>
@@ -7353,18 +7446,34 @@
           <a:p>
             <a:pPr algn="ctr"/>
             <a:r>
-              <a:rPr sz="2000" b="0">
+              <a:rPr sz="2000" b="0" dirty="0">
                 <a:solidFill>
                   <a:srgbClr val="000000"/>
                 </a:solidFill>
               </a:rPr>
-              <a:t>Full-cov VI: 0.035</a:t>
+              <a:t>Full-</a:t>
+            </a:r>
+            <a:r>
+              <a:rPr sz="2000" b="0" dirty="0" err="1">
+                <a:solidFill>
+                  <a:srgbClr val="000000"/>
+                </a:solidFill>
+              </a:rPr>
+              <a:t>cov</a:t>
+            </a:r>
+            <a:r>
+              <a:rPr sz="2000" b="0" dirty="0">
+                <a:solidFill>
+                  <a:srgbClr val="000000"/>
+                </a:solidFill>
+              </a:rPr>
+              <a:t> VI: 0.035</a:t>
             </a:r>
           </a:p>
           <a:p>
             <a:pPr algn="ctr"/>
             <a:r>
-              <a:rPr sz="2000" b="0">
+              <a:rPr sz="2000" b="0" dirty="0">
                 <a:solidFill>
                   <a:srgbClr val="000000"/>
                 </a:solidFill>
@@ -7417,6 +7526,7 @@
           <a:lstStyle/>
           <a:p>
             <a:pPr algn="ctr"/>
+            <a:endParaRPr/>
           </a:p>
         </p:txBody>
       </p:sp>
@@ -7437,7 +7547,7 @@
           <a:noFill/>
         </p:spPr>
         <p:txBody>
-          <a:bodyPr wrap="square" anchor="ctr" lIns="73152" rIns="73152" tIns="73152" bIns="73152">
+          <a:bodyPr wrap="square" lIns="73152" tIns="73152" rIns="73152" bIns="73152" anchor="ctr">
             <a:spAutoFit/>
           </a:bodyPr>
           <a:lstStyle/>
@@ -7517,6 +7627,7 @@
           <a:lstStyle/>
           <a:p>
             <a:pPr algn="ctr"/>
+            <a:endParaRPr/>
           </a:p>
         </p:txBody>
       </p:sp>
@@ -7537,7 +7648,7 @@
           <a:noFill/>
         </p:spPr>
         <p:txBody>
-          <a:bodyPr wrap="square" anchor="ctr" lIns="73152" rIns="73152" tIns="73152" bIns="73152">
+          <a:bodyPr wrap="square" lIns="73152" tIns="73152" rIns="73152" bIns="73152" anchor="ctr">
             <a:spAutoFit/>
           </a:bodyPr>
           <a:lstStyle/>
@@ -7571,7 +7682,7 @@
 </file>
 
 <file path=ppt/slides/slide12.xml><?xml version="1.0" encoding="utf-8"?>
-<p:sld xmlns:a="http://schemas.openxmlformats.org/drawingml/2006/main" xmlns:p="http://schemas.openxmlformats.org/presentationml/2006/main" xmlns:r="http://schemas.openxmlformats.org/officeDocument/2006/relationships">
+<p:sld xmlns:a="http://schemas.openxmlformats.org/drawingml/2006/main" xmlns:r="http://schemas.openxmlformats.org/officeDocument/2006/relationships" xmlns:p="http://schemas.openxmlformats.org/presentationml/2006/main">
   <p:cSld>
     <p:spTree>
       <p:nvGrpSpPr>
@@ -7579,7 +7690,14 @@
         <p:cNvGrpSpPr/>
         <p:nvPr/>
       </p:nvGrpSpPr>
-      <p:grpSpPr/>
+      <p:grpSpPr>
+        <a:xfrm>
+          <a:off x="0" y="0"/>
+          <a:ext cx="0" cy="0"/>
+          <a:chOff x="0" y="0"/>
+          <a:chExt cx="0" cy="0"/>
+        </a:xfrm>
+      </p:grpSpPr>
       <p:sp>
         <p:nvSpPr>
           <p:cNvPr id="2" name="TextBox 1"/>
@@ -7597,7 +7715,7 @@
           <a:noFill/>
         </p:spPr>
         <p:txBody>
-          <a:bodyPr wrap="square" anchor="ctr" lIns="73152" rIns="73152" tIns="73152" bIns="73152">
+          <a:bodyPr wrap="square" lIns="73152" tIns="73152" rIns="73152" bIns="73152" anchor="ctr">
             <a:spAutoFit/>
           </a:bodyPr>
           <a:lstStyle/>
@@ -7679,6 +7797,7 @@
           <a:lstStyle/>
           <a:p>
             <a:pPr algn="ctr"/>
+            <a:endParaRPr/>
           </a:p>
         </p:txBody>
       </p:sp>
@@ -7699,7 +7818,7 @@
           <a:noFill/>
         </p:spPr>
         <p:txBody>
-          <a:bodyPr wrap="square" anchor="ctr" lIns="73152" rIns="73152" tIns="73152" bIns="73152">
+          <a:bodyPr wrap="square" lIns="73152" tIns="73152" rIns="73152" bIns="73152" anchor="ctr">
             <a:spAutoFit/>
           </a:bodyPr>
           <a:lstStyle/>
@@ -7744,7 +7863,7 @@
 </file>
 
 <file path=ppt/slides/slide13.xml><?xml version="1.0" encoding="utf-8"?>
-<p:sld xmlns:a="http://schemas.openxmlformats.org/drawingml/2006/main" xmlns:p="http://schemas.openxmlformats.org/presentationml/2006/main" xmlns:r="http://schemas.openxmlformats.org/officeDocument/2006/relationships">
+<p:sld xmlns:a="http://schemas.openxmlformats.org/drawingml/2006/main" xmlns:r="http://schemas.openxmlformats.org/officeDocument/2006/relationships" xmlns:p="http://schemas.openxmlformats.org/presentationml/2006/main">
   <p:cSld>
     <p:spTree>
       <p:nvGrpSpPr>
@@ -7752,7 +7871,14 @@
         <p:cNvGrpSpPr/>
         <p:nvPr/>
       </p:nvGrpSpPr>
-      <p:grpSpPr/>
+      <p:grpSpPr>
+        <a:xfrm>
+          <a:off x="0" y="0"/>
+          <a:ext cx="0" cy="0"/>
+          <a:chOff x="0" y="0"/>
+          <a:chExt cx="0" cy="0"/>
+        </a:xfrm>
+      </p:grpSpPr>
       <p:sp>
         <p:nvSpPr>
           <p:cNvPr id="2" name="TextBox 1"/>
@@ -7770,7 +7896,7 @@
           <a:noFill/>
         </p:spPr>
         <p:txBody>
-          <a:bodyPr wrap="square" anchor="ctr" lIns="73152" rIns="73152" tIns="73152" bIns="73152">
+          <a:bodyPr wrap="square" lIns="73152" tIns="73152" rIns="73152" bIns="73152" anchor="ctr">
             <a:spAutoFit/>
           </a:bodyPr>
           <a:lstStyle/>
@@ -7804,7 +7930,7 @@
           <a:noFill/>
         </p:spPr>
         <p:txBody>
-          <a:bodyPr wrap="square" anchor="t" lIns="73152" rIns="73152" tIns="73152" bIns="73152">
+          <a:bodyPr wrap="square" lIns="73152" tIns="73152" rIns="73152" bIns="73152" anchor="t">
             <a:spAutoFit/>
           </a:bodyPr>
           <a:lstStyle/>
@@ -7840,11 +7966,41 @@
                 <a:tableStyleId>{5C22544A-7EE6-4342-B048-85BDC9FD1C3A}</a:tableStyleId>
               </a:tblPr>
               <a:tblGrid>
-                <a:gridCol w="2560320"/>
-                <a:gridCol w="1188720"/>
-                <a:gridCol w="1188720"/>
-                <a:gridCol w="1188720"/>
-                <a:gridCol w="1188720"/>
+                <a:gridCol w="2560320">
+                  <a:extLst>
+                    <a:ext uri="{9D8B030D-6E8A-4147-A177-3AD203B41FA5}">
+                      <a16:colId xmlns:a16="http://schemas.microsoft.com/office/drawing/2014/main" val="20000"/>
+                    </a:ext>
+                  </a:extLst>
+                </a:gridCol>
+                <a:gridCol w="1188720">
+                  <a:extLst>
+                    <a:ext uri="{9D8B030D-6E8A-4147-A177-3AD203B41FA5}">
+                      <a16:colId xmlns:a16="http://schemas.microsoft.com/office/drawing/2014/main" val="20001"/>
+                    </a:ext>
+                  </a:extLst>
+                </a:gridCol>
+                <a:gridCol w="1188720">
+                  <a:extLst>
+                    <a:ext uri="{9D8B030D-6E8A-4147-A177-3AD203B41FA5}">
+                      <a16:colId xmlns:a16="http://schemas.microsoft.com/office/drawing/2014/main" val="20002"/>
+                    </a:ext>
+                  </a:extLst>
+                </a:gridCol>
+                <a:gridCol w="1188720">
+                  <a:extLst>
+                    <a:ext uri="{9D8B030D-6E8A-4147-A177-3AD203B41FA5}">
+                      <a16:colId xmlns:a16="http://schemas.microsoft.com/office/drawing/2014/main" val="20003"/>
+                    </a:ext>
+                  </a:extLst>
+                </a:gridCol>
+                <a:gridCol w="1188720">
+                  <a:extLst>
+                    <a:ext uri="{9D8B030D-6E8A-4147-A177-3AD203B41FA5}">
+                      <a16:colId xmlns:a16="http://schemas.microsoft.com/office/drawing/2014/main" val="20004"/>
+                    </a:ext>
+                  </a:extLst>
+                </a:gridCol>
               </a:tblGrid>
               <a:tr h="685800">
                 <a:tc>
@@ -7863,7 +8019,7 @@
                       </a:r>
                     </a:p>
                   </a:txBody>
-                  <a:tcPr anchor="ctr" marL="73152" marR="73152">
+                  <a:tcPr marL="73152" marR="73152" anchor="ctr">
                     <a:solidFill>
                       <a:srgbClr val="2A6F8A"/>
                     </a:solidFill>
@@ -7885,7 +8041,7 @@
                       </a:r>
                     </a:p>
                   </a:txBody>
-                  <a:tcPr anchor="ctr" marL="73152" marR="73152">
+                  <a:tcPr marL="73152" marR="73152" anchor="ctr">
                     <a:solidFill>
                       <a:srgbClr val="2A6F8A"/>
                     </a:solidFill>
@@ -7907,7 +8063,7 @@
                       </a:r>
                     </a:p>
                   </a:txBody>
-                  <a:tcPr anchor="ctr" marL="73152" marR="73152">
+                  <a:tcPr marL="73152" marR="73152" anchor="ctr">
                     <a:solidFill>
                       <a:srgbClr val="2A6F8A"/>
                     </a:solidFill>
@@ -7929,7 +8085,7 @@
                       </a:r>
                     </a:p>
                   </a:txBody>
-                  <a:tcPr anchor="ctr" marL="73152" marR="73152">
+                  <a:tcPr marL="73152" marR="73152" anchor="ctr">
                     <a:solidFill>
                       <a:srgbClr val="2A6F8A"/>
                     </a:solidFill>
@@ -7951,12 +8107,17 @@
                       </a:r>
                     </a:p>
                   </a:txBody>
-                  <a:tcPr anchor="ctr" marL="73152" marR="73152">
+                  <a:tcPr marL="73152" marR="73152" anchor="ctr">
                     <a:solidFill>
                       <a:srgbClr val="2A6F8A"/>
                     </a:solidFill>
                   </a:tcPr>
                 </a:tc>
+                <a:extLst>
+                  <a:ext uri="{0D108BD9-81ED-4DB2-BD59-A6C34878D82A}">
+                    <a16:rowId xmlns:a16="http://schemas.microsoft.com/office/drawing/2014/main" val="10000"/>
+                  </a:ext>
+                </a:extLst>
               </a:tr>
               <a:tr h="685800">
                 <a:tc>
@@ -7975,7 +8136,7 @@
                       </a:r>
                     </a:p>
                   </a:txBody>
-                  <a:tcPr anchor="ctr" marL="73152" marR="73152">
+                  <a:tcPr marL="73152" marR="73152" anchor="ctr">
                     <a:solidFill>
                       <a:srgbClr val="FFFFFF"/>
                     </a:solidFill>
@@ -7997,7 +8158,7 @@
                       </a:r>
                     </a:p>
                   </a:txBody>
-                  <a:tcPr anchor="ctr" marL="73152" marR="73152">
+                  <a:tcPr marL="73152" marR="73152" anchor="ctr">
                     <a:solidFill>
                       <a:srgbClr val="FFFFFF"/>
                     </a:solidFill>
@@ -8019,7 +8180,7 @@
                       </a:r>
                     </a:p>
                   </a:txBody>
-                  <a:tcPr anchor="ctr" marL="73152" marR="73152">
+                  <a:tcPr marL="73152" marR="73152" anchor="ctr">
                     <a:solidFill>
                       <a:srgbClr val="FFFFFF"/>
                     </a:solidFill>
@@ -8041,7 +8202,7 @@
                       </a:r>
                     </a:p>
                   </a:txBody>
-                  <a:tcPr anchor="ctr" marL="73152" marR="73152">
+                  <a:tcPr marL="73152" marR="73152" anchor="ctr">
                     <a:solidFill>
                       <a:srgbClr val="FFFFFF"/>
                     </a:solidFill>
@@ -8063,12 +8224,17 @@
                       </a:r>
                     </a:p>
                   </a:txBody>
-                  <a:tcPr anchor="ctr" marL="73152" marR="73152">
+                  <a:tcPr marL="73152" marR="73152" anchor="ctr">
                     <a:solidFill>
                       <a:srgbClr val="FFFFFF"/>
                     </a:solidFill>
                   </a:tcPr>
                 </a:tc>
+                <a:extLst>
+                  <a:ext uri="{0D108BD9-81ED-4DB2-BD59-A6C34878D82A}">
+                    <a16:rowId xmlns:a16="http://schemas.microsoft.com/office/drawing/2014/main" val="10001"/>
+                  </a:ext>
+                </a:extLst>
               </a:tr>
               <a:tr h="685800">
                 <a:tc>
@@ -8087,7 +8253,7 @@
                       </a:r>
                     </a:p>
                   </a:txBody>
-                  <a:tcPr anchor="ctr" marL="73152" marR="73152">
+                  <a:tcPr marL="73152" marR="73152" anchor="ctr">
                     <a:solidFill>
                       <a:srgbClr val="F2F2F2"/>
                     </a:solidFill>
@@ -8109,7 +8275,7 @@
                       </a:r>
                     </a:p>
                   </a:txBody>
-                  <a:tcPr anchor="ctr" marL="73152" marR="73152">
+                  <a:tcPr marL="73152" marR="73152" anchor="ctr">
                     <a:solidFill>
                       <a:srgbClr val="F2F2F2"/>
                     </a:solidFill>
@@ -8131,7 +8297,7 @@
                       </a:r>
                     </a:p>
                   </a:txBody>
-                  <a:tcPr anchor="ctr" marL="73152" marR="73152">
+                  <a:tcPr marL="73152" marR="73152" anchor="ctr">
                     <a:solidFill>
                       <a:srgbClr val="F2F2F2"/>
                     </a:solidFill>
@@ -8153,7 +8319,7 @@
                       </a:r>
                     </a:p>
                   </a:txBody>
-                  <a:tcPr anchor="ctr" marL="73152" marR="73152">
+                  <a:tcPr marL="73152" marR="73152" anchor="ctr">
                     <a:solidFill>
                       <a:srgbClr val="F2F2F2"/>
                     </a:solidFill>
@@ -8175,12 +8341,17 @@
                       </a:r>
                     </a:p>
                   </a:txBody>
-                  <a:tcPr anchor="ctr" marL="73152" marR="73152">
+                  <a:tcPr marL="73152" marR="73152" anchor="ctr">
                     <a:solidFill>
                       <a:srgbClr val="F2F2F2"/>
                     </a:solidFill>
                   </a:tcPr>
                 </a:tc>
+                <a:extLst>
+                  <a:ext uri="{0D108BD9-81ED-4DB2-BD59-A6C34878D82A}">
+                    <a16:rowId xmlns:a16="http://schemas.microsoft.com/office/drawing/2014/main" val="10002"/>
+                  </a:ext>
+                </a:extLst>
               </a:tr>
               <a:tr h="685800">
                 <a:tc>
@@ -8199,7 +8370,7 @@
                       </a:r>
                     </a:p>
                   </a:txBody>
-                  <a:tcPr anchor="ctr" marL="73152" marR="73152">
+                  <a:tcPr marL="73152" marR="73152" anchor="ctr">
                     <a:solidFill>
                       <a:srgbClr val="FFFFFF"/>
                     </a:solidFill>
@@ -8221,7 +8392,7 @@
                       </a:r>
                     </a:p>
                   </a:txBody>
-                  <a:tcPr anchor="ctr" marL="73152" marR="73152">
+                  <a:tcPr marL="73152" marR="73152" anchor="ctr">
                     <a:solidFill>
                       <a:srgbClr val="FFFFFF"/>
                     </a:solidFill>
@@ -8243,7 +8414,7 @@
                       </a:r>
                     </a:p>
                   </a:txBody>
-                  <a:tcPr anchor="ctr" marL="73152" marR="73152">
+                  <a:tcPr marL="73152" marR="73152" anchor="ctr">
                     <a:solidFill>
                       <a:srgbClr val="FFFFFF"/>
                     </a:solidFill>
@@ -8265,7 +8436,7 @@
                       </a:r>
                     </a:p>
                   </a:txBody>
-                  <a:tcPr anchor="ctr" marL="73152" marR="73152">
+                  <a:tcPr marL="73152" marR="73152" anchor="ctr">
                     <a:solidFill>
                       <a:srgbClr val="FFFFFF"/>
                     </a:solidFill>
@@ -8287,12 +8458,17 @@
                       </a:r>
                     </a:p>
                   </a:txBody>
-                  <a:tcPr anchor="ctr" marL="73152" marR="73152">
+                  <a:tcPr marL="73152" marR="73152" anchor="ctr">
                     <a:solidFill>
                       <a:srgbClr val="FFFFFF"/>
                     </a:solidFill>
                   </a:tcPr>
                 </a:tc>
+                <a:extLst>
+                  <a:ext uri="{0D108BD9-81ED-4DB2-BD59-A6C34878D82A}">
+                    <a16:rowId xmlns:a16="http://schemas.microsoft.com/office/drawing/2014/main" val="10003"/>
+                  </a:ext>
+                </a:extLst>
               </a:tr>
             </a:tbl>
           </a:graphicData>
@@ -8315,7 +8491,7 @@
           <a:noFill/>
         </p:spPr>
         <p:txBody>
-          <a:bodyPr wrap="square" anchor="t" lIns="73152" rIns="73152" tIns="73152" bIns="73152">
+          <a:bodyPr wrap="square" lIns="73152" tIns="73152" rIns="73152" bIns="73152" anchor="t">
             <a:spAutoFit/>
           </a:bodyPr>
           <a:lstStyle/>
@@ -8384,7 +8560,7 @@
           <a:noFill/>
         </p:spPr>
         <p:txBody>
-          <a:bodyPr wrap="square" anchor="t" lIns="73152" rIns="73152" tIns="73152" bIns="73152">
+          <a:bodyPr wrap="square" lIns="73152" tIns="73152" rIns="73152" bIns="73152" anchor="t">
             <a:spAutoFit/>
           </a:bodyPr>
           <a:lstStyle/>
@@ -8420,9 +8596,27 @@
                 <a:tableStyleId>{5C22544A-7EE6-4342-B048-85BDC9FD1C3A}</a:tableStyleId>
               </a:tblPr>
               <a:tblGrid>
-                <a:gridCol w="3108960"/>
-                <a:gridCol w="1828800"/>
-                <a:gridCol w="2377440"/>
+                <a:gridCol w="3108960">
+                  <a:extLst>
+                    <a:ext uri="{9D8B030D-6E8A-4147-A177-3AD203B41FA5}">
+                      <a16:colId xmlns:a16="http://schemas.microsoft.com/office/drawing/2014/main" val="20000"/>
+                    </a:ext>
+                  </a:extLst>
+                </a:gridCol>
+                <a:gridCol w="1828800">
+                  <a:extLst>
+                    <a:ext uri="{9D8B030D-6E8A-4147-A177-3AD203B41FA5}">
+                      <a16:colId xmlns:a16="http://schemas.microsoft.com/office/drawing/2014/main" val="20001"/>
+                    </a:ext>
+                  </a:extLst>
+                </a:gridCol>
+                <a:gridCol w="2377440">
+                  <a:extLst>
+                    <a:ext uri="{9D8B030D-6E8A-4147-A177-3AD203B41FA5}">
+                      <a16:colId xmlns:a16="http://schemas.microsoft.com/office/drawing/2014/main" val="20002"/>
+                    </a:ext>
+                  </a:extLst>
+                </a:gridCol>
               </a:tblGrid>
               <a:tr h="658368">
                 <a:tc>
@@ -8441,7 +8635,7 @@
                       </a:r>
                     </a:p>
                   </a:txBody>
-                  <a:tcPr anchor="ctr" marL="73152" marR="73152">
+                  <a:tcPr marL="73152" marR="73152" anchor="ctr">
                     <a:solidFill>
                       <a:srgbClr val="2A6F8A"/>
                     </a:solidFill>
@@ -8463,7 +8657,7 @@
                       </a:r>
                     </a:p>
                   </a:txBody>
-                  <a:tcPr anchor="ctr" marL="73152" marR="73152">
+                  <a:tcPr marL="73152" marR="73152" anchor="ctr">
                     <a:solidFill>
                       <a:srgbClr val="2A6F8A"/>
                     </a:solidFill>
@@ -8485,12 +8679,17 @@
                       </a:r>
                     </a:p>
                   </a:txBody>
-                  <a:tcPr anchor="ctr" marL="73152" marR="73152">
+                  <a:tcPr marL="73152" marR="73152" anchor="ctr">
                     <a:solidFill>
                       <a:srgbClr val="2A6F8A"/>
                     </a:solidFill>
                   </a:tcPr>
                 </a:tc>
+                <a:extLst>
+                  <a:ext uri="{0D108BD9-81ED-4DB2-BD59-A6C34878D82A}">
+                    <a16:rowId xmlns:a16="http://schemas.microsoft.com/office/drawing/2014/main" val="10000"/>
+                  </a:ext>
+                </a:extLst>
               </a:tr>
               <a:tr h="658368">
                 <a:tc>
@@ -8509,7 +8708,7 @@
                       </a:r>
                     </a:p>
                   </a:txBody>
-                  <a:tcPr anchor="ctr" marL="73152" marR="73152">
+                  <a:tcPr marL="73152" marR="73152" anchor="ctr">
                     <a:solidFill>
                       <a:srgbClr val="FFFFFF"/>
                     </a:solidFill>
@@ -8531,7 +8730,7 @@
                       </a:r>
                     </a:p>
                   </a:txBody>
-                  <a:tcPr anchor="ctr" marL="73152" marR="73152">
+                  <a:tcPr marL="73152" marR="73152" anchor="ctr">
                     <a:solidFill>
                       <a:srgbClr val="FFFFFF"/>
                     </a:solidFill>
@@ -8553,12 +8752,17 @@
                       </a:r>
                     </a:p>
                   </a:txBody>
-                  <a:tcPr anchor="ctr" marL="73152" marR="73152">
+                  <a:tcPr marL="73152" marR="73152" anchor="ctr">
                     <a:solidFill>
                       <a:srgbClr val="FFFFFF"/>
                     </a:solidFill>
                   </a:tcPr>
                 </a:tc>
+                <a:extLst>
+                  <a:ext uri="{0D108BD9-81ED-4DB2-BD59-A6C34878D82A}">
+                    <a16:rowId xmlns:a16="http://schemas.microsoft.com/office/drawing/2014/main" val="10001"/>
+                  </a:ext>
+                </a:extLst>
               </a:tr>
               <a:tr h="658368">
                 <a:tc>
@@ -8577,7 +8781,7 @@
                       </a:r>
                     </a:p>
                   </a:txBody>
-                  <a:tcPr anchor="ctr" marL="73152" marR="73152">
+                  <a:tcPr marL="73152" marR="73152" anchor="ctr">
                     <a:solidFill>
                       <a:srgbClr val="F2F2F2"/>
                     </a:solidFill>
@@ -8599,7 +8803,7 @@
                       </a:r>
                     </a:p>
                   </a:txBody>
-                  <a:tcPr anchor="ctr" marL="73152" marR="73152">
+                  <a:tcPr marL="73152" marR="73152" anchor="ctr">
                     <a:solidFill>
                       <a:srgbClr val="F2F2F2"/>
                     </a:solidFill>
@@ -8621,12 +8825,17 @@
                       </a:r>
                     </a:p>
                   </a:txBody>
-                  <a:tcPr anchor="ctr" marL="73152" marR="73152">
+                  <a:tcPr marL="73152" marR="73152" anchor="ctr">
                     <a:solidFill>
                       <a:srgbClr val="F2F2F2"/>
                     </a:solidFill>
                   </a:tcPr>
                 </a:tc>
+                <a:extLst>
+                  <a:ext uri="{0D108BD9-81ED-4DB2-BD59-A6C34878D82A}">
+                    <a16:rowId xmlns:a16="http://schemas.microsoft.com/office/drawing/2014/main" val="10002"/>
+                  </a:ext>
+                </a:extLst>
               </a:tr>
               <a:tr h="658368">
                 <a:tc>
@@ -8645,7 +8854,7 @@
                       </a:r>
                     </a:p>
                   </a:txBody>
-                  <a:tcPr anchor="ctr" marL="73152" marR="73152">
+                  <a:tcPr marL="73152" marR="73152" anchor="ctr">
                     <a:solidFill>
                       <a:srgbClr val="FFFFFF"/>
                     </a:solidFill>
@@ -8667,7 +8876,7 @@
                       </a:r>
                     </a:p>
                   </a:txBody>
-                  <a:tcPr anchor="ctr" marL="73152" marR="73152">
+                  <a:tcPr marL="73152" marR="73152" anchor="ctr">
                     <a:solidFill>
                       <a:srgbClr val="FFFFFF"/>
                     </a:solidFill>
@@ -8689,12 +8898,17 @@
                       </a:r>
                     </a:p>
                   </a:txBody>
-                  <a:tcPr anchor="ctr" marL="73152" marR="73152">
+                  <a:tcPr marL="73152" marR="73152" anchor="ctr">
                     <a:solidFill>
                       <a:srgbClr val="FFFFFF"/>
                     </a:solidFill>
                   </a:tcPr>
                 </a:tc>
+                <a:extLst>
+                  <a:ext uri="{0D108BD9-81ED-4DB2-BD59-A6C34878D82A}">
+                    <a16:rowId xmlns:a16="http://schemas.microsoft.com/office/drawing/2014/main" val="10003"/>
+                  </a:ext>
+                </a:extLst>
               </a:tr>
               <a:tr h="658368">
                 <a:tc>
@@ -8713,7 +8927,7 @@
                       </a:r>
                     </a:p>
                   </a:txBody>
-                  <a:tcPr anchor="ctr" marL="73152" marR="73152">
+                  <a:tcPr marL="73152" marR="73152" anchor="ctr">
                     <a:solidFill>
                       <a:srgbClr val="F2F2F2"/>
                     </a:solidFill>
@@ -8735,7 +8949,7 @@
                       </a:r>
                     </a:p>
                   </a:txBody>
-                  <a:tcPr anchor="ctr" marL="73152" marR="73152">
+                  <a:tcPr marL="73152" marR="73152" anchor="ctr">
                     <a:solidFill>
                       <a:srgbClr val="F2F2F2"/>
                     </a:solidFill>
@@ -8757,12 +8971,17 @@
                       </a:r>
                     </a:p>
                   </a:txBody>
-                  <a:tcPr anchor="ctr" marL="73152" marR="73152">
+                  <a:tcPr marL="73152" marR="73152" anchor="ctr">
                     <a:solidFill>
                       <a:srgbClr val="F2F2F2"/>
                     </a:solidFill>
                   </a:tcPr>
                 </a:tc>
+                <a:extLst>
+                  <a:ext uri="{0D108BD9-81ED-4DB2-BD59-A6C34878D82A}">
+                    <a16:rowId xmlns:a16="http://schemas.microsoft.com/office/drawing/2014/main" val="10004"/>
+                  </a:ext>
+                </a:extLst>
               </a:tr>
             </a:tbl>
           </a:graphicData>
@@ -8809,6 +9028,7 @@
           <a:lstStyle/>
           <a:p>
             <a:pPr algn="ctr"/>
+            <a:endParaRPr/>
           </a:p>
         </p:txBody>
       </p:sp>
@@ -8829,7 +9049,7 @@
           <a:noFill/>
         </p:spPr>
         <p:txBody>
-          <a:bodyPr wrap="square" anchor="ctr" lIns="73152" rIns="73152" tIns="73152" bIns="73152">
+          <a:bodyPr wrap="square" lIns="73152" tIns="73152" rIns="73152" bIns="73152" anchor="ctr">
             <a:spAutoFit/>
           </a:bodyPr>
           <a:lstStyle/>
@@ -8854,14 +9074,11 @@
           </a:p>
           <a:p>
             <a:pPr algn="ctr"/>
-            <a:r>
-              <a:rPr sz="2000" b="0">
-                <a:solidFill>
-                  <a:srgbClr val="000000"/>
-                </a:solidFill>
-              </a:rPr>
-              <a:t/>
-            </a:r>
+            <a:endParaRPr sz="2000" b="0">
+              <a:solidFill>
+                <a:srgbClr val="000000"/>
+              </a:solidFill>
+            </a:endParaRPr>
           </a:p>
           <a:p>
             <a:pPr algn="ctr"/>
@@ -8893,7 +9110,7 @@
 </file>
 
 <file path=ppt/slides/slide14.xml><?xml version="1.0" encoding="utf-8"?>
-<p:sld xmlns:a="http://schemas.openxmlformats.org/drawingml/2006/main" xmlns:p="http://schemas.openxmlformats.org/presentationml/2006/main" xmlns:r="http://schemas.openxmlformats.org/officeDocument/2006/relationships">
+<p:sld xmlns:a="http://schemas.openxmlformats.org/drawingml/2006/main" xmlns:r="http://schemas.openxmlformats.org/officeDocument/2006/relationships" xmlns:p="http://schemas.openxmlformats.org/presentationml/2006/main">
   <p:cSld>
     <p:spTree>
       <p:nvGrpSpPr>
@@ -8901,7 +9118,14 @@
         <p:cNvGrpSpPr/>
         <p:nvPr/>
       </p:nvGrpSpPr>
-      <p:grpSpPr/>
+      <p:grpSpPr>
+        <a:xfrm>
+          <a:off x="0" y="0"/>
+          <a:ext cx="0" cy="0"/>
+          <a:chOff x="0" y="0"/>
+          <a:chExt cx="0" cy="0"/>
+        </a:xfrm>
+      </p:grpSpPr>
       <p:sp>
         <p:nvSpPr>
           <p:cNvPr id="2" name="TextBox 1"/>
@@ -8919,7 +9143,7 @@
           <a:noFill/>
         </p:spPr>
         <p:txBody>
-          <a:bodyPr wrap="square" anchor="ctr" lIns="73152" rIns="73152" tIns="73152" bIns="73152">
+          <a:bodyPr wrap="square" lIns="73152" tIns="73152" rIns="73152" bIns="73152" anchor="ctr">
             <a:spAutoFit/>
           </a:bodyPr>
           <a:lstStyle/>
@@ -8979,6 +9203,7 @@
           <a:lstStyle/>
           <a:p>
             <a:pPr algn="ctr"/>
+            <a:endParaRPr/>
           </a:p>
         </p:txBody>
       </p:sp>
@@ -8999,7 +9224,7 @@
           <a:noFill/>
         </p:spPr>
         <p:txBody>
-          <a:bodyPr wrap="square" anchor="t" lIns="73152" rIns="73152" tIns="73152" bIns="73152">
+          <a:bodyPr wrap="square" lIns="73152" tIns="73152" rIns="73152" bIns="73152" anchor="t">
             <a:spAutoFit/>
           </a:bodyPr>
           <a:lstStyle/>
@@ -9016,13 +9241,29 @@
           </a:p>
           <a:p>
             <a:pPr algn="l"/>
+            <a:endParaRPr sz="2000" b="1">
+              <a:solidFill>
+                <a:srgbClr val="D08F27"/>
+              </a:solidFill>
+            </a:endParaRPr>
+          </a:p>
+          <a:p>
+            <a:pPr algn="l"/>
+            <a:r>
+              <a:rPr sz="2000" b="1">
+                <a:solidFill>
+                  <a:srgbClr val="000000"/>
+                </a:solidFill>
+              </a:rPr>
+              <a:t>• The problem: </a:t>
+            </a:r>
             <a:r>
               <a:rPr sz="2000" b="0">
                 <a:solidFill>
                   <a:srgbClr val="000000"/>
                 </a:solidFill>
               </a:rPr>
-              <a:t/>
+              <a:t>Gaussian-GARCH residuals are still fat-tailed (left Q-Q).</a:t>
             </a:r>
           </a:p>
           <a:p>
@@ -9033,7 +9274,7 @@
                   <a:srgbClr val="000000"/>
                 </a:solidFill>
               </a:rPr>
-              <a:t>• The problem: </a:t>
+              <a:t>• The extension: </a:t>
             </a:r>
             <a:r>
               <a:rPr sz="2000" b="0">
@@ -9041,7 +9282,7 @@
                   <a:srgbClr val="000000"/>
                 </a:solidFill>
               </a:rPr>
-              <a:t>Gaussian-GARCH residuals are still fat-tailed (left Q-Q).</a:t>
+              <a:t>ν = 2 + exp(θν), estimated jointly with full-covariance VI (4 parameters).</a:t>
             </a:r>
           </a:p>
           <a:p>
@@ -9052,7 +9293,7 @@
                   <a:srgbClr val="000000"/>
                 </a:solidFill>
               </a:rPr>
-              <a:t>• The extension: </a:t>
+              <a:t>• The result: </a:t>
             </a:r>
             <a:r>
               <a:rPr sz="2000" b="0">
@@ -9060,38 +9301,16 @@
                   <a:srgbClr val="000000"/>
                 </a:solidFill>
               </a:rPr>
-              <a:t>ν = 2 + exp(θν), estimated jointly with full-covariance VI (4 parameters).</a:t>
+              <a:t>ν ≈ 7.4 (90% interval 5.2–10.2), far from Normal.</a:t>
             </a:r>
           </a:p>
           <a:p>
             <a:pPr algn="l"/>
-            <a:r>
-              <a:rPr sz="2000" b="1">
-                <a:solidFill>
-                  <a:srgbClr val="000000"/>
-                </a:solidFill>
-              </a:rPr>
-              <a:t>• The result: </a:t>
-            </a:r>
-            <a:r>
-              <a:rPr sz="2000" b="0">
-                <a:solidFill>
-                  <a:srgbClr val="000000"/>
-                </a:solidFill>
-              </a:rPr>
-              <a:t>ν ≈ 7.4 (90% interval 5.2–10.2), far from Normal.</a:t>
-            </a:r>
-          </a:p>
-          <a:p>
-            <a:pPr algn="l"/>
-            <a:r>
-              <a:rPr sz="2000" b="0">
-                <a:solidFill>
-                  <a:srgbClr val="000000"/>
-                </a:solidFill>
-              </a:rPr>
-              <a:t/>
-            </a:r>
+            <a:endParaRPr sz="2000" b="0">
+              <a:solidFill>
+                <a:srgbClr val="000000"/>
+              </a:solidFill>
+            </a:endParaRPr>
           </a:p>
           <a:p>
             <a:pPr algn="l"/>
@@ -9337,6 +9556,7 @@
           <a:lstStyle/>
           <a:p>
             <a:pPr algn="ctr"/>
+            <a:endParaRPr/>
           </a:p>
         </p:txBody>
       </p:sp>
@@ -9357,7 +9577,7 @@
           <a:noFill/>
         </p:spPr>
         <p:txBody>
-          <a:bodyPr wrap="square" anchor="ctr" lIns="73152" rIns="73152" tIns="73152" bIns="73152">
+          <a:bodyPr wrap="square" lIns="73152" tIns="73152" rIns="73152" bIns="73152" anchor="ctr">
             <a:spAutoFit/>
           </a:bodyPr>
           <a:lstStyle/>
@@ -9417,6 +9637,7 @@
           <a:lstStyle/>
           <a:p>
             <a:pPr algn="ctr"/>
+            <a:endParaRPr/>
           </a:p>
         </p:txBody>
       </p:sp>
@@ -9437,7 +9658,7 @@
           <a:noFill/>
         </p:spPr>
         <p:txBody>
-          <a:bodyPr wrap="square" anchor="ctr" lIns="73152" rIns="73152" tIns="73152" bIns="73152">
+          <a:bodyPr wrap="square" lIns="73152" tIns="73152" rIns="73152" bIns="73152" anchor="ctr">
             <a:spAutoFit/>
           </a:bodyPr>
           <a:lstStyle/>
@@ -9497,6 +9718,7 @@
           <a:lstStyle/>
           <a:p>
             <a:pPr algn="ctr"/>
+            <a:endParaRPr/>
           </a:p>
         </p:txBody>
       </p:sp>
@@ -9517,7 +9739,7 @@
           <a:noFill/>
         </p:spPr>
         <p:txBody>
-          <a:bodyPr wrap="square" anchor="ctr" lIns="73152" rIns="73152" tIns="73152" bIns="73152">
+          <a:bodyPr wrap="square" lIns="73152" tIns="73152" rIns="73152" bIns="73152" anchor="ctr">
             <a:spAutoFit/>
           </a:bodyPr>
           <a:lstStyle/>
@@ -9577,6 +9799,7 @@
           <a:lstStyle/>
           <a:p>
             <a:pPr algn="ctr"/>
+            <a:endParaRPr/>
           </a:p>
         </p:txBody>
       </p:sp>
@@ -9597,7 +9820,7 @@
           <a:noFill/>
         </p:spPr>
         <p:txBody>
-          <a:bodyPr wrap="square" anchor="ctr" lIns="73152" rIns="73152" tIns="73152" bIns="73152">
+          <a:bodyPr wrap="square" lIns="73152" tIns="73152" rIns="73152" bIns="73152" anchor="ctr">
             <a:spAutoFit/>
           </a:bodyPr>
           <a:lstStyle/>
@@ -9657,6 +9880,7 @@
           <a:lstStyle/>
           <a:p>
             <a:pPr algn="ctr"/>
+            <a:endParaRPr/>
           </a:p>
         </p:txBody>
       </p:sp>
@@ -9677,7 +9901,7 @@
           <a:noFill/>
         </p:spPr>
         <p:txBody>
-          <a:bodyPr wrap="square" anchor="ctr" lIns="73152" rIns="73152" tIns="73152" bIns="73152">
+          <a:bodyPr wrap="square" lIns="73152" tIns="73152" rIns="73152" bIns="73152" anchor="ctr">
             <a:spAutoFit/>
           </a:bodyPr>
           <a:lstStyle/>
@@ -9737,6 +9961,7 @@
           <a:lstStyle/>
           <a:p>
             <a:pPr algn="ctr"/>
+            <a:endParaRPr/>
           </a:p>
         </p:txBody>
       </p:sp>
@@ -9757,7 +9982,7 @@
           <a:noFill/>
         </p:spPr>
         <p:txBody>
-          <a:bodyPr wrap="square" anchor="ctr" lIns="73152" rIns="73152" tIns="73152" bIns="73152">
+          <a:bodyPr wrap="square" lIns="73152" tIns="73152" rIns="73152" bIns="73152" anchor="ctr">
             <a:spAutoFit/>
           </a:bodyPr>
           <a:lstStyle/>
@@ -9817,6 +10042,7 @@
           <a:lstStyle/>
           <a:p>
             <a:pPr algn="ctr"/>
+            <a:endParaRPr/>
           </a:p>
         </p:txBody>
       </p:sp>
@@ -9837,7 +10063,7 @@
           <a:noFill/>
         </p:spPr>
         <p:txBody>
-          <a:bodyPr wrap="square" anchor="ctr" lIns="73152" rIns="73152" tIns="73152" bIns="73152">
+          <a:bodyPr wrap="square" lIns="73152" tIns="73152" rIns="73152" bIns="73152" anchor="ctr">
             <a:spAutoFit/>
           </a:bodyPr>
           <a:lstStyle/>
@@ -9897,6 +10123,7 @@
           <a:lstStyle/>
           <a:p>
             <a:pPr algn="ctr"/>
+            <a:endParaRPr/>
           </a:p>
         </p:txBody>
       </p:sp>
@@ -9917,7 +10144,7 @@
           <a:noFill/>
         </p:spPr>
         <p:txBody>
-          <a:bodyPr wrap="square" anchor="ctr" lIns="73152" rIns="73152" tIns="73152" bIns="73152">
+          <a:bodyPr wrap="square" lIns="73152" tIns="73152" rIns="73152" bIns="73152" anchor="ctr">
             <a:spAutoFit/>
           </a:bodyPr>
           <a:lstStyle/>
@@ -9977,6 +10204,7 @@
           <a:lstStyle/>
           <a:p>
             <a:pPr algn="ctr"/>
+            <a:endParaRPr/>
           </a:p>
         </p:txBody>
       </p:sp>
@@ -9997,7 +10225,7 @@
           <a:noFill/>
         </p:spPr>
         <p:txBody>
-          <a:bodyPr wrap="square" anchor="ctr" lIns="73152" rIns="73152" tIns="73152" bIns="73152">
+          <a:bodyPr wrap="square" lIns="73152" tIns="73152" rIns="73152" bIns="73152" anchor="ctr">
             <a:spAutoFit/>
           </a:bodyPr>
           <a:lstStyle/>
@@ -10023,7 +10251,7 @@
 </file>
 
 <file path=ppt/slides/slide15.xml><?xml version="1.0" encoding="utf-8"?>
-<p:sld xmlns:a="http://schemas.openxmlformats.org/drawingml/2006/main" xmlns:p="http://schemas.openxmlformats.org/presentationml/2006/main" xmlns:r="http://schemas.openxmlformats.org/officeDocument/2006/relationships">
+<p:sld xmlns:a="http://schemas.openxmlformats.org/drawingml/2006/main" xmlns:r="http://schemas.openxmlformats.org/officeDocument/2006/relationships" xmlns:p="http://schemas.openxmlformats.org/presentationml/2006/main">
   <p:cSld>
     <p:spTree>
       <p:nvGrpSpPr>
@@ -10031,7 +10259,14 @@
         <p:cNvGrpSpPr/>
         <p:nvPr/>
       </p:nvGrpSpPr>
-      <p:grpSpPr/>
+      <p:grpSpPr>
+        <a:xfrm>
+          <a:off x="0" y="0"/>
+          <a:ext cx="0" cy="0"/>
+          <a:chOff x="0" y="0"/>
+          <a:chExt cx="0" cy="0"/>
+        </a:xfrm>
+      </p:grpSpPr>
       <p:sp>
         <p:nvSpPr>
           <p:cNvPr id="2" name="TextBox 1"/>
@@ -10049,7 +10284,7 @@
           <a:noFill/>
         </p:spPr>
         <p:txBody>
-          <a:bodyPr wrap="square" anchor="ctr" lIns="73152" rIns="73152" tIns="73152" bIns="73152">
+          <a:bodyPr wrap="square" lIns="73152" tIns="73152" rIns="73152" bIns="73152" anchor="ctr">
             <a:spAutoFit/>
           </a:bodyPr>
           <a:lstStyle/>
@@ -10107,6 +10342,7 @@
           <a:lstStyle/>
           <a:p>
             <a:pPr algn="ctr"/>
+            <a:endParaRPr/>
           </a:p>
         </p:txBody>
       </p:sp>
@@ -10127,7 +10363,7 @@
           <a:noFill/>
         </p:spPr>
         <p:txBody>
-          <a:bodyPr wrap="square" anchor="ctr" lIns="73152" rIns="73152" tIns="73152" bIns="73152">
+          <a:bodyPr wrap="square" lIns="73152" tIns="73152" rIns="73152" bIns="73152" anchor="ctr">
             <a:spAutoFit/>
           </a:bodyPr>
           <a:lstStyle/>
@@ -10235,6 +10471,7 @@
           <a:lstStyle/>
           <a:p>
             <a:pPr algn="ctr"/>
+            <a:endParaRPr/>
           </a:p>
         </p:txBody>
       </p:sp>
@@ -10255,7 +10492,7 @@
           <a:noFill/>
         </p:spPr>
         <p:txBody>
-          <a:bodyPr wrap="square" anchor="t" lIns="73152" rIns="73152" tIns="73152" bIns="73152">
+          <a:bodyPr wrap="square" lIns="73152" tIns="73152" rIns="73152" bIns="73152" anchor="t">
             <a:spAutoFit/>
           </a:bodyPr>
           <a:lstStyle/>
@@ -10272,13 +10509,29 @@
           </a:p>
           <a:p>
             <a:pPr algn="l"/>
+            <a:endParaRPr sz="1900" b="1">
+              <a:solidFill>
+                <a:srgbClr val="2A6F8A"/>
+              </a:solidFill>
+            </a:endParaRPr>
+          </a:p>
+          <a:p>
+            <a:pPr algn="l"/>
+            <a:r>
+              <a:rPr sz="1900" b="1">
+                <a:solidFill>
+                  <a:srgbClr val="000000"/>
+                </a:solidFill>
+              </a:rPr>
+              <a:t>Test NLL:  </a:t>
+            </a:r>
             <a:r>
               <a:rPr sz="1900" b="0">
                 <a:solidFill>
                   <a:srgbClr val="000000"/>
                 </a:solidFill>
               </a:rPr>
-              <a:t/>
+              <a:t>MCMC +0.12 · BBVI +0.14</a:t>
             </a:r>
           </a:p>
           <a:p>
@@ -10289,7 +10542,7 @@
                   <a:srgbClr val="000000"/>
                 </a:solidFill>
               </a:rPr>
-              <a:t>Test NLL:  </a:t>
+              <a:t>Test QLIK: </a:t>
             </a:r>
             <a:r>
               <a:rPr sz="1900" b="0">
@@ -10297,7 +10550,7 @@
                   <a:srgbClr val="000000"/>
                 </a:solidFill>
               </a:rPr>
-              <a:t>MCMC +0.12 · BBVI +0.14</a:t>
+              <a:t>MCMC +0.25 · BBVI +0.28</a:t>
             </a:r>
           </a:p>
           <a:p>
@@ -10308,7 +10561,7 @@
                   <a:srgbClr val="000000"/>
                 </a:solidFill>
               </a:rPr>
-              <a:t>Test QLIK: </a:t>
+              <a:t>Train NLL: </a:t>
             </a:r>
             <a:r>
               <a:rPr sz="1900" b="0">
@@ -10316,38 +10569,16 @@
                   <a:srgbClr val="000000"/>
                 </a:solidFill>
               </a:rPr>
-              <a:t>MCMC +0.25 · BBVI +0.28</a:t>
+              <a:t>QML lowest for 100% of stocks (it maximises it by design)</a:t>
             </a:r>
           </a:p>
           <a:p>
             <a:pPr algn="l"/>
-            <a:r>
-              <a:rPr sz="1900" b="1">
-                <a:solidFill>
-                  <a:srgbClr val="000000"/>
-                </a:solidFill>
-              </a:rPr>
-              <a:t>Train NLL: </a:t>
-            </a:r>
-            <a:r>
-              <a:rPr sz="1900" b="0">
-                <a:solidFill>
-                  <a:srgbClr val="000000"/>
-                </a:solidFill>
-              </a:rPr>
-              <a:t>QML lowest for 100% of stocks (it maximises it by design)</a:t>
-            </a:r>
-          </a:p>
-          <a:p>
-            <a:pPr algn="l"/>
-            <a:r>
-              <a:rPr sz="1900" b="0">
-                <a:solidFill>
-                  <a:srgbClr val="000000"/>
-                </a:solidFill>
-              </a:rPr>
-              <a:t/>
-            </a:r>
+            <a:endParaRPr sz="1900" b="0">
+              <a:solidFill>
+                <a:srgbClr val="000000"/>
+              </a:solidFill>
+            </a:endParaRPr>
           </a:p>
           <a:p>
             <a:pPr algn="l"/>
@@ -10405,6 +10636,7 @@
           <a:lstStyle/>
           <a:p>
             <a:pPr algn="ctr"/>
+            <a:endParaRPr/>
           </a:p>
         </p:txBody>
       </p:sp>
@@ -10425,7 +10657,7 @@
           <a:noFill/>
         </p:spPr>
         <p:txBody>
-          <a:bodyPr wrap="square" anchor="t" lIns="73152" rIns="73152" tIns="73152" bIns="73152">
+          <a:bodyPr wrap="square" lIns="73152" tIns="73152" rIns="73152" bIns="73152" anchor="t">
             <a:spAutoFit/>
           </a:bodyPr>
           <a:lstStyle/>
@@ -10496,6 +10728,7 @@
           <a:lstStyle/>
           <a:p>
             <a:pPr algn="ctr"/>
+            <a:endParaRPr/>
           </a:p>
         </p:txBody>
       </p:sp>
@@ -10516,7 +10749,7 @@
           <a:noFill/>
         </p:spPr>
         <p:txBody>
-          <a:bodyPr wrap="square" anchor="t" lIns="73152" rIns="73152" tIns="73152" bIns="73152">
+          <a:bodyPr wrap="square" lIns="73152" tIns="73152" rIns="73152" bIns="73152" anchor="t">
             <a:spAutoFit/>
           </a:bodyPr>
           <a:lstStyle/>
@@ -10553,7 +10786,7 @@
 </file>
 
 <file path=ppt/slides/slide16.xml><?xml version="1.0" encoding="utf-8"?>
-<p:sld xmlns:a="http://schemas.openxmlformats.org/drawingml/2006/main" xmlns:p="http://schemas.openxmlformats.org/presentationml/2006/main" xmlns:r="http://schemas.openxmlformats.org/officeDocument/2006/relationships">
+<p:sld xmlns:a="http://schemas.openxmlformats.org/drawingml/2006/main" xmlns:r="http://schemas.openxmlformats.org/officeDocument/2006/relationships" xmlns:p="http://schemas.openxmlformats.org/presentationml/2006/main">
   <p:cSld>
     <p:spTree>
       <p:nvGrpSpPr>
@@ -10561,7 +10794,14 @@
         <p:cNvGrpSpPr/>
         <p:nvPr/>
       </p:nvGrpSpPr>
-      <p:grpSpPr/>
+      <p:grpSpPr>
+        <a:xfrm>
+          <a:off x="0" y="0"/>
+          <a:ext cx="0" cy="0"/>
+          <a:chOff x="0" y="0"/>
+          <a:chExt cx="0" cy="0"/>
+        </a:xfrm>
+      </p:grpSpPr>
       <p:sp>
         <p:nvSpPr>
           <p:cNvPr id="2" name="TextBox 1"/>
@@ -10579,7 +10819,7 @@
           <a:noFill/>
         </p:spPr>
         <p:txBody>
-          <a:bodyPr wrap="square" anchor="ctr" lIns="73152" rIns="73152" tIns="73152" bIns="73152">
+          <a:bodyPr wrap="square" lIns="73152" tIns="73152" rIns="73152" bIns="73152" anchor="ctr">
             <a:spAutoFit/>
           </a:bodyPr>
           <a:lstStyle/>
@@ -10639,6 +10879,7 @@
           <a:lstStyle/>
           <a:p>
             <a:pPr algn="ctr"/>
+            <a:endParaRPr/>
           </a:p>
         </p:txBody>
       </p:sp>
@@ -10659,7 +10900,7 @@
           <a:noFill/>
         </p:spPr>
         <p:txBody>
-          <a:bodyPr wrap="square" anchor="t" lIns="73152" rIns="73152" tIns="73152" bIns="73152">
+          <a:bodyPr wrap="square" lIns="73152" tIns="73152" rIns="73152" bIns="73152" anchor="t">
             <a:spAutoFit/>
           </a:bodyPr>
           <a:lstStyle/>
@@ -10676,14 +10917,11 @@
           </a:p>
           <a:p>
             <a:pPr algn="l"/>
-            <a:r>
-              <a:rPr sz="2300" b="0">
-                <a:solidFill>
-                  <a:srgbClr val="000000"/>
-                </a:solidFill>
-              </a:rPr>
-              <a:t/>
-            </a:r>
+            <a:endParaRPr sz="2300" b="1">
+              <a:solidFill>
+                <a:srgbClr val="000000"/>
+              </a:solidFill>
+            </a:endParaRPr>
           </a:p>
           <a:p>
             <a:pPr algn="l"/>
@@ -10768,6 +11006,7 @@
           <a:lstStyle/>
           <a:p>
             <a:pPr algn="ctr"/>
+            <a:endParaRPr/>
           </a:p>
         </p:txBody>
       </p:sp>
@@ -10788,7 +11027,7 @@
           <a:noFill/>
         </p:spPr>
         <p:txBody>
-          <a:bodyPr wrap="square" anchor="t" lIns="73152" rIns="73152" tIns="73152" bIns="73152">
+          <a:bodyPr wrap="square" lIns="73152" tIns="73152" rIns="73152" bIns="73152" anchor="t">
             <a:spAutoFit/>
           </a:bodyPr>
           <a:lstStyle/>
@@ -10805,14 +11044,11 @@
           </a:p>
           <a:p>
             <a:pPr algn="l"/>
-            <a:r>
-              <a:rPr sz="2300" b="0">
-                <a:solidFill>
-                  <a:srgbClr val="000000"/>
-                </a:solidFill>
-              </a:rPr>
-              <a:t/>
-            </a:r>
+            <a:endParaRPr sz="2300" b="1">
+              <a:solidFill>
+                <a:srgbClr val="000000"/>
+              </a:solidFill>
+            </a:endParaRPr>
           </a:p>
           <a:p>
             <a:pPr algn="l"/>
@@ -10897,6 +11133,7 @@
           <a:lstStyle/>
           <a:p>
             <a:pPr algn="ctr"/>
+            <a:endParaRPr/>
           </a:p>
         </p:txBody>
       </p:sp>
@@ -10917,7 +11154,7 @@
           <a:noFill/>
         </p:spPr>
         <p:txBody>
-          <a:bodyPr wrap="square" anchor="t" lIns="73152" rIns="73152" tIns="73152" bIns="73152">
+          <a:bodyPr wrap="square" lIns="73152" tIns="73152" rIns="73152" bIns="73152" anchor="t">
             <a:spAutoFit/>
           </a:bodyPr>
           <a:lstStyle/>
@@ -10934,14 +11171,11 @@
           </a:p>
           <a:p>
             <a:pPr algn="l"/>
-            <a:r>
-              <a:rPr sz="2300" b="0">
-                <a:solidFill>
-                  <a:srgbClr val="000000"/>
-                </a:solidFill>
-              </a:rPr>
-              <a:t/>
-            </a:r>
+            <a:endParaRPr sz="2300" b="1">
+              <a:solidFill>
+                <a:srgbClr val="000000"/>
+              </a:solidFill>
+            </a:endParaRPr>
           </a:p>
           <a:p>
             <a:pPr algn="l"/>
@@ -11000,7 +11234,7 @@
           <a:noFill/>
         </p:spPr>
         <p:txBody>
-          <a:bodyPr wrap="square" anchor="t" lIns="73152" rIns="73152" tIns="73152" bIns="73152">
+          <a:bodyPr wrap="square" lIns="73152" tIns="73152" rIns="73152" bIns="73152" anchor="t">
             <a:spAutoFit/>
           </a:bodyPr>
           <a:lstStyle/>
@@ -11045,7 +11279,7 @@
           <a:noFill/>
         </p:spPr>
         <p:txBody>
-          <a:bodyPr wrap="square" anchor="t" lIns="73152" rIns="73152" tIns="73152" bIns="73152">
+          <a:bodyPr wrap="square" lIns="73152" tIns="73152" rIns="73152" bIns="73152" anchor="t">
             <a:spAutoFit/>
           </a:bodyPr>
           <a:lstStyle/>
@@ -11079,7 +11313,7 @@
 </file>
 
 <file path=ppt/slides/slide17.xml><?xml version="1.0" encoding="utf-8"?>
-<p:sld xmlns:a="http://schemas.openxmlformats.org/drawingml/2006/main" xmlns:p="http://schemas.openxmlformats.org/presentationml/2006/main" xmlns:r="http://schemas.openxmlformats.org/officeDocument/2006/relationships">
+<p:sld xmlns:a="http://schemas.openxmlformats.org/drawingml/2006/main" xmlns:r="http://schemas.openxmlformats.org/officeDocument/2006/relationships" xmlns:p="http://schemas.openxmlformats.org/presentationml/2006/main">
   <p:cSld>
     <p:spTree>
       <p:nvGrpSpPr>
@@ -11087,7 +11321,14 @@
         <p:cNvGrpSpPr/>
         <p:nvPr/>
       </p:nvGrpSpPr>
-      <p:grpSpPr/>
+      <p:grpSpPr>
+        <a:xfrm>
+          <a:off x="0" y="0"/>
+          <a:ext cx="0" cy="0"/>
+          <a:chOff x="0" y="0"/>
+          <a:chExt cx="0" cy="0"/>
+        </a:xfrm>
+      </p:grpSpPr>
       <p:sp>
         <p:nvSpPr>
           <p:cNvPr id="2" name="TextBox 1"/>
@@ -11105,7 +11346,7 @@
           <a:noFill/>
         </p:spPr>
         <p:txBody>
-          <a:bodyPr wrap="square" anchor="ctr" lIns="73152" rIns="73152" tIns="73152" bIns="73152">
+          <a:bodyPr wrap="square" lIns="73152" tIns="73152" rIns="73152" bIns="73152" anchor="ctr">
             <a:spAutoFit/>
           </a:bodyPr>
           <a:lstStyle/>
@@ -11141,8 +11382,20 @@
                 <a:tableStyleId>{5C22544A-7EE6-4342-B048-85BDC9FD1C3A}</a:tableStyleId>
               </a:tblPr>
               <a:tblGrid>
-                <a:gridCol w="4206240"/>
-                <a:gridCol w="10789920"/>
+                <a:gridCol w="4206240">
+                  <a:extLst>
+                    <a:ext uri="{9D8B030D-6E8A-4147-A177-3AD203B41FA5}">
+                      <a16:colId xmlns:a16="http://schemas.microsoft.com/office/drawing/2014/main" val="20000"/>
+                    </a:ext>
+                  </a:extLst>
+                </a:gridCol>
+                <a:gridCol w="10789920">
+                  <a:extLst>
+                    <a:ext uri="{9D8B030D-6E8A-4147-A177-3AD203B41FA5}">
+                      <a16:colId xmlns:a16="http://schemas.microsoft.com/office/drawing/2014/main" val="20001"/>
+                    </a:ext>
+                  </a:extLst>
+                </a:gridCol>
               </a:tblGrid>
               <a:tr h="555673">
                 <a:tc>
@@ -11161,7 +11414,7 @@
                       </a:r>
                     </a:p>
                   </a:txBody>
-                  <a:tcPr anchor="ctr" marL="73152" marR="73152">
+                  <a:tcPr marL="73152" marR="73152" anchor="ctr">
                     <a:solidFill>
                       <a:srgbClr val="2A6F8A"/>
                     </a:solidFill>
@@ -11183,12 +11436,17 @@
                       </a:r>
                     </a:p>
                   </a:txBody>
-                  <a:tcPr anchor="ctr" marL="73152" marR="73152">
+                  <a:tcPr marL="73152" marR="73152" anchor="ctr">
                     <a:solidFill>
                       <a:srgbClr val="2A6F8A"/>
                     </a:solidFill>
                   </a:tcPr>
                 </a:tc>
+                <a:extLst>
+                  <a:ext uri="{0D108BD9-81ED-4DB2-BD59-A6C34878D82A}">
+                    <a16:rowId xmlns:a16="http://schemas.microsoft.com/office/drawing/2014/main" val="10000"/>
+                  </a:ext>
+                </a:extLst>
               </a:tr>
               <a:tr h="555673">
                 <a:tc>
@@ -11207,7 +11465,7 @@
                       </a:r>
                     </a:p>
                   </a:txBody>
-                  <a:tcPr anchor="ctr" marL="73152" marR="73152">
+                  <a:tcPr marL="73152" marR="73152" anchor="ctr">
                     <a:solidFill>
                       <a:srgbClr val="FFFFFF"/>
                     </a:solidFill>
@@ -11229,12 +11487,17 @@
                       </a:r>
                     </a:p>
                   </a:txBody>
-                  <a:tcPr anchor="ctr" marL="73152" marR="73152">
+                  <a:tcPr marL="73152" marR="73152" anchor="ctr">
                     <a:solidFill>
                       <a:srgbClr val="FFFFFF"/>
                     </a:solidFill>
                   </a:tcPr>
                 </a:tc>
+                <a:extLst>
+                  <a:ext uri="{0D108BD9-81ED-4DB2-BD59-A6C34878D82A}">
+                    <a16:rowId xmlns:a16="http://schemas.microsoft.com/office/drawing/2014/main" val="10001"/>
+                  </a:ext>
+                </a:extLst>
               </a:tr>
               <a:tr h="555673">
                 <a:tc>
@@ -11253,7 +11516,7 @@
                       </a:r>
                     </a:p>
                   </a:txBody>
-                  <a:tcPr anchor="ctr" marL="73152" marR="73152">
+                  <a:tcPr marL="73152" marR="73152" anchor="ctr">
                     <a:solidFill>
                       <a:srgbClr val="F2F2F2"/>
                     </a:solidFill>
@@ -11275,12 +11538,17 @@
                       </a:r>
                     </a:p>
                   </a:txBody>
-                  <a:tcPr anchor="ctr" marL="73152" marR="73152">
+                  <a:tcPr marL="73152" marR="73152" anchor="ctr">
                     <a:solidFill>
                       <a:srgbClr val="F2F2F2"/>
                     </a:solidFill>
                   </a:tcPr>
                 </a:tc>
+                <a:extLst>
+                  <a:ext uri="{0D108BD9-81ED-4DB2-BD59-A6C34878D82A}">
+                    <a16:rowId xmlns:a16="http://schemas.microsoft.com/office/drawing/2014/main" val="10002"/>
+                  </a:ext>
+                </a:extLst>
               </a:tr>
               <a:tr h="555673">
                 <a:tc>
@@ -11299,7 +11567,7 @@
                       </a:r>
                     </a:p>
                   </a:txBody>
-                  <a:tcPr anchor="ctr" marL="73152" marR="73152">
+                  <a:tcPr marL="73152" marR="73152" anchor="ctr">
                     <a:solidFill>
                       <a:srgbClr val="FFFFFF"/>
                     </a:solidFill>
@@ -11321,12 +11589,17 @@
                       </a:r>
                     </a:p>
                   </a:txBody>
-                  <a:tcPr anchor="ctr" marL="73152" marR="73152">
+                  <a:tcPr marL="73152" marR="73152" anchor="ctr">
                     <a:solidFill>
                       <a:srgbClr val="FFFFFF"/>
                     </a:solidFill>
                   </a:tcPr>
                 </a:tc>
+                <a:extLst>
+                  <a:ext uri="{0D108BD9-81ED-4DB2-BD59-A6C34878D82A}">
+                    <a16:rowId xmlns:a16="http://schemas.microsoft.com/office/drawing/2014/main" val="10003"/>
+                  </a:ext>
+                </a:extLst>
               </a:tr>
               <a:tr h="555673">
                 <a:tc>
@@ -11345,7 +11618,7 @@
                       </a:r>
                     </a:p>
                   </a:txBody>
-                  <a:tcPr anchor="ctr" marL="73152" marR="73152">
+                  <a:tcPr marL="73152" marR="73152" anchor="ctr">
                     <a:solidFill>
                       <a:srgbClr val="F2F2F2"/>
                     </a:solidFill>
@@ -11367,12 +11640,17 @@
                       </a:r>
                     </a:p>
                   </a:txBody>
-                  <a:tcPr anchor="ctr" marL="73152" marR="73152">
+                  <a:tcPr marL="73152" marR="73152" anchor="ctr">
                     <a:solidFill>
                       <a:srgbClr val="F2F2F2"/>
                     </a:solidFill>
                   </a:tcPr>
                 </a:tc>
+                <a:extLst>
+                  <a:ext uri="{0D108BD9-81ED-4DB2-BD59-A6C34878D82A}">
+                    <a16:rowId xmlns:a16="http://schemas.microsoft.com/office/drawing/2014/main" val="10004"/>
+                  </a:ext>
+                </a:extLst>
               </a:tr>
               <a:tr h="555673">
                 <a:tc>
@@ -11391,7 +11669,7 @@
                       </a:r>
                     </a:p>
                   </a:txBody>
-                  <a:tcPr anchor="ctr" marL="73152" marR="73152">
+                  <a:tcPr marL="73152" marR="73152" anchor="ctr">
                     <a:solidFill>
                       <a:srgbClr val="FFFFFF"/>
                     </a:solidFill>
@@ -11413,12 +11691,17 @@
                       </a:r>
                     </a:p>
                   </a:txBody>
-                  <a:tcPr anchor="ctr" marL="73152" marR="73152">
+                  <a:tcPr marL="73152" marR="73152" anchor="ctr">
                     <a:solidFill>
                       <a:srgbClr val="FFFFFF"/>
                     </a:solidFill>
                   </a:tcPr>
                 </a:tc>
+                <a:extLst>
+                  <a:ext uri="{0D108BD9-81ED-4DB2-BD59-A6C34878D82A}">
+                    <a16:rowId xmlns:a16="http://schemas.microsoft.com/office/drawing/2014/main" val="10005"/>
+                  </a:ext>
+                </a:extLst>
               </a:tr>
               <a:tr h="555673">
                 <a:tc>
@@ -11437,7 +11720,7 @@
                       </a:r>
                     </a:p>
                   </a:txBody>
-                  <a:tcPr anchor="ctr" marL="73152" marR="73152">
+                  <a:tcPr marL="73152" marR="73152" anchor="ctr">
                     <a:solidFill>
                       <a:srgbClr val="F2F2F2"/>
                     </a:solidFill>
@@ -11459,12 +11742,17 @@
                       </a:r>
                     </a:p>
                   </a:txBody>
-                  <a:tcPr anchor="ctr" marL="73152" marR="73152">
+                  <a:tcPr marL="73152" marR="73152" anchor="ctr">
                     <a:solidFill>
                       <a:srgbClr val="F2F2F2"/>
                     </a:solidFill>
                   </a:tcPr>
                 </a:tc>
+                <a:extLst>
+                  <a:ext uri="{0D108BD9-81ED-4DB2-BD59-A6C34878D82A}">
+                    <a16:rowId xmlns:a16="http://schemas.microsoft.com/office/drawing/2014/main" val="10006"/>
+                  </a:ext>
+                </a:extLst>
               </a:tr>
               <a:tr h="555673">
                 <a:tc>
@@ -11483,7 +11771,7 @@
                       </a:r>
                     </a:p>
                   </a:txBody>
-                  <a:tcPr anchor="ctr" marL="73152" marR="73152">
+                  <a:tcPr marL="73152" marR="73152" anchor="ctr">
                     <a:solidFill>
                       <a:srgbClr val="FFFFFF"/>
                     </a:solidFill>
@@ -11496,7 +11784,7 @@
                     <a:p>
                       <a:pPr algn="l"/>
                       <a:r>
-                        <a:rPr sz="2100" b="0">
+                        <a:rPr sz="2100" b="0" dirty="0">
                           <a:solidFill>
                             <a:srgbClr val="000000"/>
                           </a:solidFill>
@@ -11505,12 +11793,17 @@
                       </a:r>
                     </a:p>
                   </a:txBody>
-                  <a:tcPr anchor="ctr" marL="73152" marR="73152">
+                  <a:tcPr marL="73152" marR="73152" anchor="ctr">
                     <a:solidFill>
                       <a:srgbClr val="FFFFFF"/>
                     </a:solidFill>
                   </a:tcPr>
                 </a:tc>
+                <a:extLst>
+                  <a:ext uri="{0D108BD9-81ED-4DB2-BD59-A6C34878D82A}">
+                    <a16:rowId xmlns:a16="http://schemas.microsoft.com/office/drawing/2014/main" val="10007"/>
+                  </a:ext>
+                </a:extLst>
               </a:tr>
               <a:tr h="555673">
                 <a:tc>
@@ -11529,7 +11822,7 @@
                       </a:r>
                     </a:p>
                   </a:txBody>
-                  <a:tcPr anchor="ctr" marL="73152" marR="73152">
+                  <a:tcPr marL="73152" marR="73152" anchor="ctr">
                     <a:solidFill>
                       <a:srgbClr val="F2F2F2"/>
                     </a:solidFill>
@@ -11551,12 +11844,17 @@
                       </a:r>
                     </a:p>
                   </a:txBody>
-                  <a:tcPr anchor="ctr" marL="73152" marR="73152">
+                  <a:tcPr marL="73152" marR="73152" anchor="ctr">
                     <a:solidFill>
                       <a:srgbClr val="F2F2F2"/>
                     </a:solidFill>
                   </a:tcPr>
                 </a:tc>
+                <a:extLst>
+                  <a:ext uri="{0D108BD9-81ED-4DB2-BD59-A6C34878D82A}">
+                    <a16:rowId xmlns:a16="http://schemas.microsoft.com/office/drawing/2014/main" val="10008"/>
+                  </a:ext>
+                </a:extLst>
               </a:tr>
               <a:tr h="555673">
                 <a:tc>
@@ -11575,7 +11873,7 @@
                       </a:r>
                     </a:p>
                   </a:txBody>
-                  <a:tcPr anchor="ctr" marL="73152" marR="73152">
+                  <a:tcPr marL="73152" marR="73152" anchor="ctr">
                     <a:solidFill>
                       <a:srgbClr val="FFFFFF"/>
                     </a:solidFill>
@@ -11597,12 +11895,17 @@
                       </a:r>
                     </a:p>
                   </a:txBody>
-                  <a:tcPr anchor="ctr" marL="73152" marR="73152">
+                  <a:tcPr marL="73152" marR="73152" anchor="ctr">
                     <a:solidFill>
                       <a:srgbClr val="FFFFFF"/>
                     </a:solidFill>
                   </a:tcPr>
                 </a:tc>
+                <a:extLst>
+                  <a:ext uri="{0D108BD9-81ED-4DB2-BD59-A6C34878D82A}">
+                    <a16:rowId xmlns:a16="http://schemas.microsoft.com/office/drawing/2014/main" val="10009"/>
+                  </a:ext>
+                </a:extLst>
               </a:tr>
               <a:tr h="555673">
                 <a:tc>
@@ -11621,7 +11924,7 @@
                       </a:r>
                     </a:p>
                   </a:txBody>
-                  <a:tcPr anchor="ctr" marL="73152" marR="73152">
+                  <a:tcPr marL="73152" marR="73152" anchor="ctr">
                     <a:solidFill>
                       <a:srgbClr val="F2F2F2"/>
                     </a:solidFill>
@@ -11643,12 +11946,17 @@
                       </a:r>
                     </a:p>
                   </a:txBody>
-                  <a:tcPr anchor="ctr" marL="73152" marR="73152">
+                  <a:tcPr marL="73152" marR="73152" anchor="ctr">
                     <a:solidFill>
                       <a:srgbClr val="F2F2F2"/>
                     </a:solidFill>
                   </a:tcPr>
                 </a:tc>
+                <a:extLst>
+                  <a:ext uri="{0D108BD9-81ED-4DB2-BD59-A6C34878D82A}">
+                    <a16:rowId xmlns:a16="http://schemas.microsoft.com/office/drawing/2014/main" val="10010"/>
+                  </a:ext>
+                </a:extLst>
               </a:tr>
               <a:tr h="555673">
                 <a:tc>
@@ -11667,7 +11975,7 @@
                       </a:r>
                     </a:p>
                   </a:txBody>
-                  <a:tcPr anchor="ctr" marL="73152" marR="73152">
+                  <a:tcPr marL="73152" marR="73152" anchor="ctr">
                     <a:solidFill>
                       <a:srgbClr val="FFFFFF"/>
                     </a:solidFill>
@@ -11689,12 +11997,17 @@
                       </a:r>
                     </a:p>
                   </a:txBody>
-                  <a:tcPr anchor="ctr" marL="73152" marR="73152">
+                  <a:tcPr marL="73152" marR="73152" anchor="ctr">
                     <a:solidFill>
                       <a:srgbClr val="FFFFFF"/>
                     </a:solidFill>
                   </a:tcPr>
                 </a:tc>
+                <a:extLst>
+                  <a:ext uri="{0D108BD9-81ED-4DB2-BD59-A6C34878D82A}">
+                    <a16:rowId xmlns:a16="http://schemas.microsoft.com/office/drawing/2014/main" val="10011"/>
+                  </a:ext>
+                </a:extLst>
               </a:tr>
               <a:tr h="555684">
                 <a:tc>
@@ -11713,7 +12026,7 @@
                       </a:r>
                     </a:p>
                   </a:txBody>
-                  <a:tcPr anchor="ctr" marL="73152" marR="73152">
+                  <a:tcPr marL="73152" marR="73152" anchor="ctr">
                     <a:solidFill>
                       <a:srgbClr val="F2F2F2"/>
                     </a:solidFill>
@@ -11726,7 +12039,7 @@
                     <a:p>
                       <a:pPr algn="l"/>
                       <a:r>
-                        <a:rPr sz="2100" b="0">
+                        <a:rPr sz="2100" b="0" dirty="0">
                           <a:solidFill>
                             <a:srgbClr val="000000"/>
                           </a:solidFill>
@@ -11735,12 +12048,17 @@
                       </a:r>
                     </a:p>
                   </a:txBody>
-                  <a:tcPr anchor="ctr" marL="73152" marR="73152">
+                  <a:tcPr marL="73152" marR="73152" anchor="ctr">
                     <a:solidFill>
                       <a:srgbClr val="F2F2F2"/>
                     </a:solidFill>
                   </a:tcPr>
                 </a:tc>
+                <a:extLst>
+                  <a:ext uri="{0D108BD9-81ED-4DB2-BD59-A6C34878D82A}">
+                    <a16:rowId xmlns:a16="http://schemas.microsoft.com/office/drawing/2014/main" val="10012"/>
+                  </a:ext>
+                </a:extLst>
               </a:tr>
             </a:tbl>
           </a:graphicData>
@@ -11755,7 +12073,7 @@
 </file>
 
 <file path=ppt/slides/slide18.xml><?xml version="1.0" encoding="utf-8"?>
-<p:sld xmlns:a="http://schemas.openxmlformats.org/drawingml/2006/main" xmlns:p="http://schemas.openxmlformats.org/presentationml/2006/main" xmlns:r="http://schemas.openxmlformats.org/officeDocument/2006/relationships">
+<p:sld xmlns:a="http://schemas.openxmlformats.org/drawingml/2006/main" xmlns:r="http://schemas.openxmlformats.org/officeDocument/2006/relationships" xmlns:p="http://schemas.openxmlformats.org/presentationml/2006/main">
   <p:cSld>
     <p:spTree>
       <p:nvGrpSpPr>
@@ -11763,7 +12081,14 @@
         <p:cNvGrpSpPr/>
         <p:nvPr/>
       </p:nvGrpSpPr>
-      <p:grpSpPr/>
+      <p:grpSpPr>
+        <a:xfrm>
+          <a:off x="0" y="0"/>
+          <a:ext cx="0" cy="0"/>
+          <a:chOff x="0" y="0"/>
+          <a:chExt cx="0" cy="0"/>
+        </a:xfrm>
+      </p:grpSpPr>
       <p:sp>
         <p:nvSpPr>
           <p:cNvPr id="2" name="TextBox 1"/>
@@ -11781,7 +12106,7 @@
           <a:noFill/>
         </p:spPr>
         <p:txBody>
-          <a:bodyPr wrap="square" anchor="ctr" lIns="73152" rIns="73152" tIns="73152" bIns="73152">
+          <a:bodyPr wrap="square" lIns="73152" tIns="73152" rIns="73152" bIns="73152" anchor="ctr">
             <a:spAutoFit/>
           </a:bodyPr>
           <a:lstStyle/>
@@ -11815,7 +12140,7 @@
           <a:noFill/>
         </p:spPr>
         <p:txBody>
-          <a:bodyPr wrap="square" anchor="t" lIns="73152" rIns="73152" tIns="73152" bIns="73152">
+          <a:bodyPr wrap="square" lIns="73152" tIns="73152" rIns="73152" bIns="73152" anchor="t">
             <a:spAutoFit/>
           </a:bodyPr>
           <a:lstStyle/>
@@ -11929,7 +12254,7 @@
 </file>
 
 <file path=ppt/slides/slide2.xml><?xml version="1.0" encoding="utf-8"?>
-<p:sld xmlns:a="http://schemas.openxmlformats.org/drawingml/2006/main" xmlns:p="http://schemas.openxmlformats.org/presentationml/2006/main" xmlns:r="http://schemas.openxmlformats.org/officeDocument/2006/relationships">
+<p:sld xmlns:a="http://schemas.openxmlformats.org/drawingml/2006/main" xmlns:r="http://schemas.openxmlformats.org/officeDocument/2006/relationships" xmlns:p="http://schemas.openxmlformats.org/presentationml/2006/main">
   <p:cSld>
     <p:spTree>
       <p:nvGrpSpPr>
@@ -11937,7 +12262,14 @@
         <p:cNvGrpSpPr/>
         <p:nvPr/>
       </p:nvGrpSpPr>
-      <p:grpSpPr/>
+      <p:grpSpPr>
+        <a:xfrm>
+          <a:off x="0" y="0"/>
+          <a:ext cx="0" cy="0"/>
+          <a:chOff x="0" y="0"/>
+          <a:chExt cx="0" cy="0"/>
+        </a:xfrm>
+      </p:grpSpPr>
       <p:sp>
         <p:nvSpPr>
           <p:cNvPr id="2" name="TextBox 1"/>
@@ -11955,7 +12287,7 @@
           <a:noFill/>
         </p:spPr>
         <p:txBody>
-          <a:bodyPr wrap="square" anchor="ctr" lIns="73152" rIns="73152" tIns="73152" bIns="73152">
+          <a:bodyPr wrap="square" lIns="73152" tIns="73152" rIns="73152" bIns="73152" anchor="ctr">
             <a:spAutoFit/>
           </a:bodyPr>
           <a:lstStyle/>
@@ -12067,6 +12399,7 @@
           <a:lstStyle/>
           <a:p>
             <a:pPr algn="ctr"/>
+            <a:endParaRPr/>
           </a:p>
         </p:txBody>
       </p:sp>
@@ -12087,7 +12420,7 @@
           <a:noFill/>
         </p:spPr>
         <p:txBody>
-          <a:bodyPr wrap="square" anchor="ctr" lIns="73152" rIns="73152" tIns="73152" bIns="73152">
+          <a:bodyPr wrap="square" lIns="73152" tIns="73152" rIns="73152" bIns="73152" anchor="ctr">
             <a:spAutoFit/>
           </a:bodyPr>
           <a:lstStyle/>
@@ -12199,6 +12532,7 @@
           <a:lstStyle/>
           <a:p>
             <a:pPr algn="ctr"/>
+            <a:endParaRPr/>
           </a:p>
         </p:txBody>
       </p:sp>
@@ -12219,7 +12553,7 @@
           <a:noFill/>
         </p:spPr>
         <p:txBody>
-          <a:bodyPr wrap="square" anchor="ctr" lIns="73152" rIns="73152" tIns="73152" bIns="73152">
+          <a:bodyPr wrap="square" lIns="73152" tIns="73152" rIns="73152" bIns="73152" anchor="ctr">
             <a:spAutoFit/>
           </a:bodyPr>
           <a:lstStyle/>
@@ -12331,6 +12665,7 @@
           <a:lstStyle/>
           <a:p>
             <a:pPr algn="ctr"/>
+            <a:endParaRPr/>
           </a:p>
         </p:txBody>
       </p:sp>
@@ -12351,7 +12686,7 @@
           <a:noFill/>
         </p:spPr>
         <p:txBody>
-          <a:bodyPr wrap="square" anchor="ctr" lIns="73152" rIns="73152" tIns="73152" bIns="73152">
+          <a:bodyPr wrap="square" lIns="73152" tIns="73152" rIns="73152" bIns="73152" anchor="ctr">
             <a:spAutoFit/>
           </a:bodyPr>
           <a:lstStyle/>
@@ -12463,6 +12798,7 @@
           <a:lstStyle/>
           <a:p>
             <a:pPr algn="ctr"/>
+            <a:endParaRPr/>
           </a:p>
         </p:txBody>
       </p:sp>
@@ -12483,7 +12819,7 @@
           <a:noFill/>
         </p:spPr>
         <p:txBody>
-          <a:bodyPr wrap="square" anchor="ctr" lIns="73152" rIns="73152" tIns="73152" bIns="73152">
+          <a:bodyPr wrap="square" lIns="73152" tIns="73152" rIns="73152" bIns="73152" anchor="ctr">
             <a:spAutoFit/>
           </a:bodyPr>
           <a:lstStyle/>
@@ -12541,6 +12877,7 @@
           <a:lstStyle/>
           <a:p>
             <a:pPr algn="ctr"/>
+            <a:endParaRPr/>
           </a:p>
         </p:txBody>
       </p:sp>
@@ -12561,7 +12898,7 @@
           <a:noFill/>
         </p:spPr>
         <p:txBody>
-          <a:bodyPr wrap="square" anchor="ctr" lIns="73152" rIns="73152" tIns="73152" bIns="73152">
+          <a:bodyPr wrap="square" lIns="73152" tIns="73152" rIns="73152" bIns="73152" anchor="ctr">
             <a:spAutoFit/>
           </a:bodyPr>
           <a:lstStyle/>
@@ -14261,6 +14598,7 @@
           <a:lstStyle/>
           <a:p>
             <a:pPr algn="ctr"/>
+            <a:endParaRPr/>
           </a:p>
         </p:txBody>
       </p:sp>
@@ -14281,7 +14619,7 @@
           <a:noFill/>
         </p:spPr>
         <p:txBody>
-          <a:bodyPr wrap="square" anchor="ctr" lIns="73152" rIns="73152" tIns="73152" bIns="73152">
+          <a:bodyPr wrap="square" lIns="73152" tIns="73152" rIns="73152" bIns="73152" anchor="ctr">
             <a:spAutoFit/>
           </a:bodyPr>
           <a:lstStyle/>
@@ -15047,7 +15385,7 @@
                     <m:oMathParaPr>
                       <m:jc m:val="center"/>
                     </m:oMathParaPr>
-                    <m:oMath xmlns:m="http://schemas.openxmlformats.org/officeDocument/2006/math">
+                    <m:oMath>
                       <m:r>
                         <a:rPr lang="en-US" sz="4800" b="0" i="1" smtClean="0">
                           <a:latin typeface="Cambria Math" panose="02040503050406030204" pitchFamily="18" charset="0"/>
@@ -15145,7 +15483,7 @@
                     <m:oMathParaPr>
                       <m:jc m:val="center"/>
                     </m:oMathParaPr>
-                    <m:oMath xmlns:m="http://schemas.openxmlformats.org/officeDocument/2006/math">
+                    <m:oMath>
                       <m:r>
                         <a:rPr lang="en-US" sz="4800" b="0" i="1" smtClean="0">
                           <a:latin typeface="Cambria Math" panose="02040503050406030204" pitchFamily="18" charset="0"/>
@@ -15288,7 +15626,7 @@
 </file>
 
 <file path=ppt/slides/slide6.xml><?xml version="1.0" encoding="utf-8"?>
-<p:sld xmlns:a="http://schemas.openxmlformats.org/drawingml/2006/main" xmlns:p="http://schemas.openxmlformats.org/presentationml/2006/main" xmlns:r="http://schemas.openxmlformats.org/officeDocument/2006/relationships">
+<p:sld xmlns:a="http://schemas.openxmlformats.org/drawingml/2006/main" xmlns:r="http://schemas.openxmlformats.org/officeDocument/2006/relationships" xmlns:p="http://schemas.openxmlformats.org/presentationml/2006/main">
   <p:cSld>
     <p:spTree>
       <p:nvGrpSpPr>
@@ -15296,7 +15634,14 @@
         <p:cNvGrpSpPr/>
         <p:nvPr/>
       </p:nvGrpSpPr>
-      <p:grpSpPr/>
+      <p:grpSpPr>
+        <a:xfrm>
+          <a:off x="0" y="0"/>
+          <a:ext cx="0" cy="0"/>
+          <a:chOff x="0" y="0"/>
+          <a:chExt cx="0" cy="0"/>
+        </a:xfrm>
+      </p:grpSpPr>
       <p:sp>
         <p:nvSpPr>
           <p:cNvPr id="2" name="TextBox 1"/>
@@ -15314,7 +15659,7 @@
           <a:noFill/>
         </p:spPr>
         <p:txBody>
-          <a:bodyPr wrap="square" anchor="ctr" lIns="73152" rIns="73152" tIns="73152" bIns="73152">
+          <a:bodyPr wrap="square" lIns="73152" tIns="73152" rIns="73152" bIns="73152" anchor="ctr">
             <a:spAutoFit/>
           </a:bodyPr>
           <a:lstStyle/>
@@ -15374,6 +15719,7 @@
           <a:lstStyle/>
           <a:p>
             <a:pPr algn="ctr"/>
+            <a:endParaRPr/>
           </a:p>
         </p:txBody>
       </p:sp>
@@ -15394,7 +15740,7 @@
           <a:noFill/>
         </p:spPr>
         <p:txBody>
-          <a:bodyPr wrap="square" anchor="t" lIns="73152" rIns="73152" tIns="73152" bIns="73152">
+          <a:bodyPr wrap="square" lIns="73152" tIns="73152" rIns="73152" bIns="73152" anchor="t">
             <a:spAutoFit/>
           </a:bodyPr>
           <a:lstStyle/>
@@ -15428,7 +15774,7 @@
           <a:noFill/>
         </p:spPr>
         <p:txBody>
-          <a:bodyPr wrap="square" anchor="t" lIns="73152" rIns="73152" tIns="73152" bIns="73152">
+          <a:bodyPr wrap="square" lIns="73152" tIns="73152" rIns="73152" bIns="73152" anchor="t">
             <a:spAutoFit/>
           </a:bodyPr>
           <a:lstStyle/>
@@ -15462,7 +15808,7 @@
           <a:noFill/>
         </p:spPr>
         <p:txBody>
-          <a:bodyPr wrap="square" anchor="t" lIns="73152" rIns="73152" tIns="73152" bIns="73152">
+          <a:bodyPr wrap="square" lIns="73152" tIns="73152" rIns="73152" bIns="73152" anchor="t">
             <a:spAutoFit/>
           </a:bodyPr>
           <a:lstStyle/>
@@ -15479,14 +15825,11 @@
           </a:p>
           <a:p>
             <a:pPr algn="ctr"/>
-            <a:r>
-              <a:rPr sz="2200" b="0">
-                <a:solidFill>
-                  <a:srgbClr val="000000"/>
-                </a:solidFill>
-              </a:rPr>
-              <a:t/>
-            </a:r>
+            <a:endParaRPr sz="2200" b="0">
+              <a:solidFill>
+                <a:srgbClr val="000000"/>
+              </a:solidFill>
+            </a:endParaRPr>
           </a:p>
           <a:p>
             <a:pPr algn="ctr"/>
@@ -15544,6 +15887,7 @@
           <a:lstStyle/>
           <a:p>
             <a:pPr algn="ctr"/>
+            <a:endParaRPr/>
           </a:p>
         </p:txBody>
       </p:sp>
@@ -15564,7 +15908,7 @@
           <a:noFill/>
         </p:spPr>
         <p:txBody>
-          <a:bodyPr wrap="square" anchor="t" lIns="73152" rIns="73152" tIns="73152" bIns="73152">
+          <a:bodyPr wrap="square" lIns="73152" tIns="73152" rIns="73152" bIns="73152" anchor="t">
             <a:spAutoFit/>
           </a:bodyPr>
           <a:lstStyle/>
@@ -15598,7 +15942,7 @@
           <a:noFill/>
         </p:spPr>
         <p:txBody>
-          <a:bodyPr wrap="square" anchor="t" lIns="73152" rIns="73152" tIns="73152" bIns="73152">
+          <a:bodyPr wrap="square" lIns="73152" tIns="73152" rIns="73152" bIns="73152" anchor="t">
             <a:spAutoFit/>
           </a:bodyPr>
           <a:lstStyle/>
@@ -15694,6 +16038,7 @@
           <a:lstStyle/>
           <a:p>
             <a:pPr algn="ctr"/>
+            <a:endParaRPr/>
           </a:p>
         </p:txBody>
       </p:sp>
@@ -15714,7 +16059,7 @@
           <a:noFill/>
         </p:spPr>
         <p:txBody>
-          <a:bodyPr wrap="square" anchor="ctr" lIns="73152" rIns="73152" tIns="73152" bIns="73152">
+          <a:bodyPr wrap="square" lIns="73152" tIns="73152" rIns="73152" bIns="73152" anchor="ctr">
             <a:spAutoFit/>
           </a:bodyPr>
           <a:lstStyle/>
@@ -15748,7 +16093,7 @@
           <a:noFill/>
         </p:spPr>
         <p:txBody>
-          <a:bodyPr wrap="square" anchor="t" lIns="73152" rIns="73152" tIns="73152" bIns="73152">
+          <a:bodyPr wrap="square" lIns="73152" tIns="73152" rIns="73152" bIns="73152" anchor="t">
             <a:spAutoFit/>
           </a:bodyPr>
           <a:lstStyle/>
@@ -15818,7 +16163,7 @@
           <a:noFill/>
         </p:spPr>
         <p:txBody>
-          <a:bodyPr wrap="square" anchor="t" lIns="73152" rIns="73152" tIns="73152" bIns="73152">
+          <a:bodyPr wrap="square" lIns="73152" tIns="73152" rIns="73152" bIns="73152" anchor="t">
             <a:spAutoFit/>
           </a:bodyPr>
           <a:lstStyle/>
@@ -15914,6 +16259,7 @@
           <a:lstStyle/>
           <a:p>
             <a:pPr algn="ctr"/>
+            <a:endParaRPr/>
           </a:p>
         </p:txBody>
       </p:sp>
@@ -15934,7 +16280,7 @@
           <a:noFill/>
         </p:spPr>
         <p:txBody>
-          <a:bodyPr wrap="square" anchor="ctr" lIns="73152" rIns="73152" tIns="73152" bIns="73152">
+          <a:bodyPr wrap="square" lIns="73152" tIns="73152" rIns="73152" bIns="73152" anchor="ctr">
             <a:spAutoFit/>
           </a:bodyPr>
           <a:lstStyle/>
@@ -15968,7 +16314,7 @@
           <a:noFill/>
         </p:spPr>
         <p:txBody>
-          <a:bodyPr wrap="square" anchor="t" lIns="73152" rIns="73152" tIns="73152" bIns="73152">
+          <a:bodyPr wrap="square" lIns="73152" tIns="73152" rIns="73152" bIns="73152" anchor="t">
             <a:spAutoFit/>
           </a:bodyPr>
           <a:lstStyle/>
@@ -16038,7 +16384,7 @@
           <a:noFill/>
         </p:spPr>
         <p:txBody>
-          <a:bodyPr wrap="square" anchor="t" lIns="73152" rIns="73152" tIns="73152" bIns="73152">
+          <a:bodyPr wrap="square" lIns="73152" tIns="73152" rIns="73152" bIns="73152" anchor="t">
             <a:spAutoFit/>
           </a:bodyPr>
           <a:lstStyle/>
@@ -16134,6 +16480,7 @@
           <a:lstStyle/>
           <a:p>
             <a:pPr algn="ctr"/>
+            <a:endParaRPr/>
           </a:p>
         </p:txBody>
       </p:sp>
@@ -16154,7 +16501,7 @@
           <a:noFill/>
         </p:spPr>
         <p:txBody>
-          <a:bodyPr wrap="square" anchor="ctr" lIns="73152" rIns="73152" tIns="73152" bIns="73152">
+          <a:bodyPr wrap="square" lIns="73152" tIns="73152" rIns="73152" bIns="73152" anchor="ctr">
             <a:spAutoFit/>
           </a:bodyPr>
           <a:lstStyle/>
@@ -16188,7 +16535,7 @@
           <a:noFill/>
         </p:spPr>
         <p:txBody>
-          <a:bodyPr wrap="square" anchor="t" lIns="73152" rIns="73152" tIns="73152" bIns="73152">
+          <a:bodyPr wrap="square" lIns="73152" tIns="73152" rIns="73152" bIns="73152" anchor="t">
             <a:spAutoFit/>
           </a:bodyPr>
           <a:lstStyle/>
@@ -16284,6 +16631,7 @@
           <a:lstStyle/>
           <a:p>
             <a:pPr algn="ctr"/>
+            <a:endParaRPr/>
           </a:p>
         </p:txBody>
       </p:sp>
@@ -16304,7 +16652,7 @@
           <a:noFill/>
         </p:spPr>
         <p:txBody>
-          <a:bodyPr wrap="square" anchor="t" lIns="73152" rIns="73152" tIns="73152" bIns="73152">
+          <a:bodyPr wrap="square" lIns="73152" tIns="73152" rIns="73152" bIns="73152" anchor="t">
             <a:spAutoFit/>
           </a:bodyPr>
           <a:lstStyle/>
@@ -16338,7 +16686,7 @@
           <a:noFill/>
         </p:spPr>
         <p:txBody>
-          <a:bodyPr wrap="square" anchor="t" lIns="73152" rIns="73152" tIns="73152" bIns="73152">
+          <a:bodyPr wrap="square" lIns="73152" tIns="73152" rIns="73152" bIns="73152" anchor="t">
             <a:spAutoFit/>
           </a:bodyPr>
           <a:lstStyle/>
@@ -16453,6 +16801,7 @@
           <a:lstStyle/>
           <a:p>
             <a:pPr algn="ctr"/>
+            <a:endParaRPr/>
           </a:p>
         </p:txBody>
       </p:sp>
@@ -16473,7 +16822,7 @@
           <a:noFill/>
         </p:spPr>
         <p:txBody>
-          <a:bodyPr wrap="square" anchor="ctr" lIns="73152" rIns="73152" tIns="73152" bIns="73152">
+          <a:bodyPr wrap="square" lIns="73152" tIns="73152" rIns="73152" bIns="73152" anchor="ctr">
             <a:spAutoFit/>
           </a:bodyPr>
           <a:lstStyle/>
@@ -16553,6 +16902,7 @@
           <a:lstStyle/>
           <a:p>
             <a:pPr algn="ctr"/>
+            <a:endParaRPr/>
           </a:p>
         </p:txBody>
       </p:sp>
@@ -16573,7 +16923,7 @@
           <a:noFill/>
         </p:spPr>
         <p:txBody>
-          <a:bodyPr wrap="square" anchor="ctr" lIns="73152" rIns="73152" tIns="73152" bIns="73152">
+          <a:bodyPr wrap="square" lIns="73152" tIns="73152" rIns="73152" bIns="73152" anchor="ctr">
             <a:spAutoFit/>
           </a:bodyPr>
           <a:lstStyle/>
@@ -17017,10 +17367,7 @@
                 <a:pPr algn="ctr"/>
                 <a14:m>
                   <m:oMathPara xmlns:m="http://schemas.openxmlformats.org/officeDocument/2006/math">
-                    <m:oMathParaPr>
-                      <m:jc m:val="centerGroup"/>
-                    </m:oMathParaPr>
-                    <m:oMath xmlns:m="http://schemas.openxmlformats.org/officeDocument/2006/math">
+                    <m:oMath>
                       <m:r>
                         <a:rPr lang="en-US" sz="2800" i="1" smtClean="0">
                           <a:solidFill>
@@ -17820,10 +18167,7 @@
                 <a:pPr algn="ctr"/>
                 <a14:m>
                   <m:oMathPara xmlns:m="http://schemas.openxmlformats.org/officeDocument/2006/math">
-                    <m:oMathParaPr>
-                      <m:jc m:val="centerGroup"/>
-                    </m:oMathParaPr>
-                    <m:oMath xmlns:m="http://schemas.openxmlformats.org/officeDocument/2006/math">
+                    <m:oMath>
                       <m:r>
                         <m:rPr>
                           <m:sty m:val="p"/>
@@ -18218,7 +18562,7 @@
                     <m:oMathParaPr>
                       <m:jc m:val="center"/>
                     </m:oMathParaPr>
-                    <m:oMath xmlns:m="http://schemas.openxmlformats.org/officeDocument/2006/math">
+                    <m:oMath>
                       <m:r>
                         <a:rPr lang="en-US" sz="2000" b="0" i="1" smtClean="0">
                           <a:latin typeface="Cambria Math" panose="02040503050406030204" pitchFamily="18" charset="0"/>
@@ -18316,7 +18660,7 @@
                     <m:oMathParaPr>
                       <m:jc m:val="center"/>
                     </m:oMathParaPr>
-                    <m:oMath xmlns:m="http://schemas.openxmlformats.org/officeDocument/2006/math">
+                    <m:oMath>
                       <m:r>
                         <a:rPr lang="en-US" sz="2000" b="0" i="1" smtClean="0">
                           <a:latin typeface="Cambria Math" panose="02040503050406030204" pitchFamily="18" charset="0"/>
@@ -18550,6 +18894,7 @@
           <a:lstStyle/>
           <a:p>
             <a:pPr algn="ctr"/>
+            <a:endParaRPr/>
           </a:p>
         </p:txBody>
       </p:sp>
@@ -18570,7 +18915,7 @@
           <a:noFill/>
         </p:spPr>
         <p:txBody>
-          <a:bodyPr wrap="square" anchor="t" lIns="73152" rIns="73152" tIns="73152" bIns="73152">
+          <a:bodyPr wrap="square" lIns="73152" tIns="73152" rIns="73152" bIns="73152" anchor="t">
             <a:spAutoFit/>
           </a:bodyPr>
           <a:lstStyle/>
@@ -18615,7 +18960,7 @@
           <a:noFill/>
         </p:spPr>
         <p:txBody>
-          <a:bodyPr wrap="square" anchor="t" lIns="73152" rIns="73152" tIns="73152" bIns="73152">
+          <a:bodyPr wrap="square" lIns="73152" tIns="73152" rIns="73152" bIns="73152" anchor="t">
             <a:spAutoFit/>
           </a:bodyPr>
           <a:lstStyle/>
@@ -18643,14 +18988,11 @@
           </a:p>
           <a:p>
             <a:pPr algn="l"/>
-            <a:r>
-              <a:rPr sz="2100" b="0">
-                <a:solidFill>
-                  <a:srgbClr val="000000"/>
-                </a:solidFill>
-              </a:rPr>
-              <a:t/>
-            </a:r>
+            <a:endParaRPr sz="2100" b="0">
+              <a:solidFill>
+                <a:srgbClr val="000000"/>
+              </a:solidFill>
+            </a:endParaRPr>
           </a:p>
           <a:p>
             <a:pPr algn="l"/>
@@ -18717,7 +19059,7 @@
 </file>
 
 <file path=ppt/slides/slide8.xml><?xml version="1.0" encoding="utf-8"?>
-<p:sld xmlns:a="http://schemas.openxmlformats.org/drawingml/2006/main" xmlns:p="http://schemas.openxmlformats.org/presentationml/2006/main" xmlns:r="http://schemas.openxmlformats.org/officeDocument/2006/relationships">
+<p:sld xmlns:a="http://schemas.openxmlformats.org/drawingml/2006/main" xmlns:r="http://schemas.openxmlformats.org/officeDocument/2006/relationships" xmlns:p="http://schemas.openxmlformats.org/presentationml/2006/main">
   <p:cSld>
     <p:spTree>
       <p:nvGrpSpPr>
@@ -18725,7 +19067,14 @@
         <p:cNvGrpSpPr/>
         <p:nvPr/>
       </p:nvGrpSpPr>
-      <p:grpSpPr/>
+      <p:grpSpPr>
+        <a:xfrm>
+          <a:off x="0" y="0"/>
+          <a:ext cx="0" cy="0"/>
+          <a:chOff x="0" y="0"/>
+          <a:chExt cx="0" cy="0"/>
+        </a:xfrm>
+      </p:grpSpPr>
       <p:sp>
         <p:nvSpPr>
           <p:cNvPr id="2" name="TextBox 1"/>
@@ -18743,7 +19092,7 @@
           <a:noFill/>
         </p:spPr>
         <p:txBody>
-          <a:bodyPr wrap="square" anchor="ctr" lIns="73152" rIns="73152" tIns="73152" bIns="73152">
+          <a:bodyPr wrap="square" lIns="73152" tIns="73152" rIns="73152" bIns="73152" anchor="ctr">
             <a:spAutoFit/>
           </a:bodyPr>
           <a:lstStyle/>
@@ -18777,7 +19126,7 @@
           <a:noFill/>
         </p:spPr>
         <p:txBody>
-          <a:bodyPr wrap="square" anchor="t" lIns="73152" rIns="73152" tIns="73152" bIns="73152">
+          <a:bodyPr wrap="square" lIns="73152" tIns="73152" rIns="73152" bIns="73152" anchor="t">
             <a:spAutoFit/>
           </a:bodyPr>
           <a:lstStyle/>
@@ -18813,8 +19162,20 @@
                 <a:tableStyleId>{5C22544A-7EE6-4342-B048-85BDC9FD1C3A}</a:tableStyleId>
               </a:tblPr>
               <a:tblGrid>
-                <a:gridCol w="1737360"/>
-                <a:gridCol w="5577840"/>
+                <a:gridCol w="1737360">
+                  <a:extLst>
+                    <a:ext uri="{9D8B030D-6E8A-4147-A177-3AD203B41FA5}">
+                      <a16:colId xmlns:a16="http://schemas.microsoft.com/office/drawing/2014/main" val="20000"/>
+                    </a:ext>
+                  </a:extLst>
+                </a:gridCol>
+                <a:gridCol w="5577840">
+                  <a:extLst>
+                    <a:ext uri="{9D8B030D-6E8A-4147-A177-3AD203B41FA5}">
+                      <a16:colId xmlns:a16="http://schemas.microsoft.com/office/drawing/2014/main" val="20001"/>
+                    </a:ext>
+                  </a:extLst>
+                </a:gridCol>
               </a:tblGrid>
               <a:tr h="809897">
                 <a:tc>
@@ -18833,7 +19194,7 @@
                       </a:r>
                     </a:p>
                   </a:txBody>
-                  <a:tcPr anchor="ctr" marL="73152" marR="73152">
+                  <a:tcPr marL="73152" marR="73152" anchor="ctr">
                     <a:solidFill>
                       <a:srgbClr val="2A6F8A"/>
                     </a:solidFill>
@@ -18855,12 +19216,17 @@
                       </a:r>
                     </a:p>
                   </a:txBody>
-                  <a:tcPr anchor="ctr" marL="73152" marR="73152">
+                  <a:tcPr marL="73152" marR="73152" anchor="ctr">
                     <a:solidFill>
                       <a:srgbClr val="2A6F8A"/>
                     </a:solidFill>
                   </a:tcPr>
                 </a:tc>
+                <a:extLst>
+                  <a:ext uri="{0D108BD9-81ED-4DB2-BD59-A6C34878D82A}">
+                    <a16:rowId xmlns:a16="http://schemas.microsoft.com/office/drawing/2014/main" val="10000"/>
+                  </a:ext>
+                </a:extLst>
               </a:tr>
               <a:tr h="809897">
                 <a:tc>
@@ -18879,7 +19245,7 @@
                       </a:r>
                     </a:p>
                   </a:txBody>
-                  <a:tcPr anchor="ctr" marL="73152" marR="73152">
+                  <a:tcPr marL="73152" marR="73152" anchor="ctr">
                     <a:solidFill>
                       <a:srgbClr val="FFFFFF"/>
                     </a:solidFill>
@@ -18901,12 +19267,17 @@
                       </a:r>
                     </a:p>
                   </a:txBody>
-                  <a:tcPr anchor="ctr" marL="73152" marR="73152">
+                  <a:tcPr marL="73152" marR="73152" anchor="ctr">
                     <a:solidFill>
                       <a:srgbClr val="FFFFFF"/>
                     </a:solidFill>
                   </a:tcPr>
                 </a:tc>
+                <a:extLst>
+                  <a:ext uri="{0D108BD9-81ED-4DB2-BD59-A6C34878D82A}">
+                    <a16:rowId xmlns:a16="http://schemas.microsoft.com/office/drawing/2014/main" val="10001"/>
+                  </a:ext>
+                </a:extLst>
               </a:tr>
               <a:tr h="809897">
                 <a:tc>
@@ -18925,7 +19296,7 @@
                       </a:r>
                     </a:p>
                   </a:txBody>
-                  <a:tcPr anchor="ctr" marL="73152" marR="73152">
+                  <a:tcPr marL="73152" marR="73152" anchor="ctr">
                     <a:solidFill>
                       <a:srgbClr val="F2F2F2"/>
                     </a:solidFill>
@@ -18947,12 +19318,17 @@
                       </a:r>
                     </a:p>
                   </a:txBody>
-                  <a:tcPr anchor="ctr" marL="73152" marR="73152">
+                  <a:tcPr marL="73152" marR="73152" anchor="ctr">
                     <a:solidFill>
                       <a:srgbClr val="F2F2F2"/>
                     </a:solidFill>
                   </a:tcPr>
                 </a:tc>
+                <a:extLst>
+                  <a:ext uri="{0D108BD9-81ED-4DB2-BD59-A6C34878D82A}">
+                    <a16:rowId xmlns:a16="http://schemas.microsoft.com/office/drawing/2014/main" val="10002"/>
+                  </a:ext>
+                </a:extLst>
               </a:tr>
               <a:tr h="809897">
                 <a:tc>
@@ -18971,7 +19347,7 @@
                       </a:r>
                     </a:p>
                   </a:txBody>
-                  <a:tcPr anchor="ctr" marL="73152" marR="73152">
+                  <a:tcPr marL="73152" marR="73152" anchor="ctr">
                     <a:solidFill>
                       <a:srgbClr val="FFFFFF"/>
                     </a:solidFill>
@@ -18993,12 +19369,17 @@
                       </a:r>
                     </a:p>
                   </a:txBody>
-                  <a:tcPr anchor="ctr" marL="73152" marR="73152">
+                  <a:tcPr marL="73152" marR="73152" anchor="ctr">
                     <a:solidFill>
                       <a:srgbClr val="FFFFFF"/>
                     </a:solidFill>
                   </a:tcPr>
                 </a:tc>
+                <a:extLst>
+                  <a:ext uri="{0D108BD9-81ED-4DB2-BD59-A6C34878D82A}">
+                    <a16:rowId xmlns:a16="http://schemas.microsoft.com/office/drawing/2014/main" val="10003"/>
+                  </a:ext>
+                </a:extLst>
               </a:tr>
               <a:tr h="809897">
                 <a:tc>
@@ -19017,7 +19398,7 @@
                       </a:r>
                     </a:p>
                   </a:txBody>
-                  <a:tcPr anchor="ctr" marL="73152" marR="73152">
+                  <a:tcPr marL="73152" marR="73152" anchor="ctr">
                     <a:solidFill>
                       <a:srgbClr val="F2F2F2"/>
                     </a:solidFill>
@@ -19039,12 +19420,17 @@
                       </a:r>
                     </a:p>
                   </a:txBody>
-                  <a:tcPr anchor="ctr" marL="73152" marR="73152">
+                  <a:tcPr marL="73152" marR="73152" anchor="ctr">
                     <a:solidFill>
                       <a:srgbClr val="F2F2F2"/>
                     </a:solidFill>
                   </a:tcPr>
                 </a:tc>
+                <a:extLst>
+                  <a:ext uri="{0D108BD9-81ED-4DB2-BD59-A6C34878D82A}">
+                    <a16:rowId xmlns:a16="http://schemas.microsoft.com/office/drawing/2014/main" val="10004"/>
+                  </a:ext>
+                </a:extLst>
               </a:tr>
               <a:tr h="809897">
                 <a:tc>
@@ -19063,7 +19449,7 @@
                       </a:r>
                     </a:p>
                   </a:txBody>
-                  <a:tcPr anchor="ctr" marL="73152" marR="73152">
+                  <a:tcPr marL="73152" marR="73152" anchor="ctr">
                     <a:solidFill>
                       <a:srgbClr val="FFFFFF"/>
                     </a:solidFill>
@@ -19085,12 +19471,17 @@
                       </a:r>
                     </a:p>
                   </a:txBody>
-                  <a:tcPr anchor="ctr" marL="73152" marR="73152">
+                  <a:tcPr marL="73152" marR="73152" anchor="ctr">
                     <a:solidFill>
                       <a:srgbClr val="FFFFFF"/>
                     </a:solidFill>
                   </a:tcPr>
                 </a:tc>
+                <a:extLst>
+                  <a:ext uri="{0D108BD9-81ED-4DB2-BD59-A6C34878D82A}">
+                    <a16:rowId xmlns:a16="http://schemas.microsoft.com/office/drawing/2014/main" val="10005"/>
+                  </a:ext>
+                </a:extLst>
               </a:tr>
               <a:tr h="809898">
                 <a:tc>
@@ -19109,7 +19500,7 @@
                       </a:r>
                     </a:p>
                   </a:txBody>
-                  <a:tcPr anchor="ctr" marL="73152" marR="73152">
+                  <a:tcPr marL="73152" marR="73152" anchor="ctr">
                     <a:solidFill>
                       <a:srgbClr val="F2F2F2"/>
                     </a:solidFill>
@@ -19131,12 +19522,17 @@
                       </a:r>
                     </a:p>
                   </a:txBody>
-                  <a:tcPr anchor="ctr" marL="73152" marR="73152">
+                  <a:tcPr marL="73152" marR="73152" anchor="ctr">
                     <a:solidFill>
                       <a:srgbClr val="F2F2F2"/>
                     </a:solidFill>
                   </a:tcPr>
                 </a:tc>
+                <a:extLst>
+                  <a:ext uri="{0D108BD9-81ED-4DB2-BD59-A6C34878D82A}">
+                    <a16:rowId xmlns:a16="http://schemas.microsoft.com/office/drawing/2014/main" val="10006"/>
+                  </a:ext>
+                </a:extLst>
               </a:tr>
             </a:tbl>
           </a:graphicData>
@@ -19194,7 +19590,7 @@
           <a:noFill/>
         </p:spPr>
         <p:txBody>
-          <a:bodyPr wrap="square" anchor="t" lIns="73152" rIns="73152" tIns="73152" bIns="73152">
+          <a:bodyPr wrap="square" lIns="73152" tIns="73152" rIns="73152" bIns="73152" anchor="t">
             <a:spAutoFit/>
           </a:bodyPr>
           <a:lstStyle/>
@@ -19278,6 +19674,7 @@
           <a:lstStyle/>
           <a:p>
             <a:pPr algn="ctr"/>
+            <a:endParaRPr/>
           </a:p>
         </p:txBody>
       </p:sp>
@@ -19298,7 +19695,7 @@
           <a:noFill/>
         </p:spPr>
         <p:txBody>
-          <a:bodyPr wrap="square" anchor="ctr" lIns="73152" rIns="73152" tIns="73152" bIns="73152">
+          <a:bodyPr wrap="square" lIns="73152" tIns="73152" rIns="73152" bIns="73152" anchor="ctr">
             <a:spAutoFit/>
           </a:bodyPr>
           <a:lstStyle/>
@@ -19332,7 +19729,7 @@
 </file>
 
 <file path=ppt/slides/slide9.xml><?xml version="1.0" encoding="utf-8"?>
-<p:sld xmlns:a="http://schemas.openxmlformats.org/drawingml/2006/main" xmlns:p="http://schemas.openxmlformats.org/presentationml/2006/main" xmlns:r="http://schemas.openxmlformats.org/officeDocument/2006/relationships">
+<p:sld xmlns:a="http://schemas.openxmlformats.org/drawingml/2006/main" xmlns:r="http://schemas.openxmlformats.org/officeDocument/2006/relationships" xmlns:p="http://schemas.openxmlformats.org/presentationml/2006/main">
   <p:cSld>
     <p:spTree>
       <p:nvGrpSpPr>
@@ -19340,7 +19737,14 @@
         <p:cNvGrpSpPr/>
         <p:nvPr/>
       </p:nvGrpSpPr>
-      <p:grpSpPr/>
+      <p:grpSpPr>
+        <a:xfrm>
+          <a:off x="0" y="0"/>
+          <a:ext cx="0" cy="0"/>
+          <a:chOff x="0" y="0"/>
+          <a:chExt cx="0" cy="0"/>
+        </a:xfrm>
+      </p:grpSpPr>
       <p:sp>
         <p:nvSpPr>
           <p:cNvPr id="2" name="TextBox 1"/>
@@ -19358,7 +19762,7 @@
           <a:noFill/>
         </p:spPr>
         <p:txBody>
-          <a:bodyPr wrap="square" anchor="ctr" lIns="73152" rIns="73152" tIns="73152" bIns="73152">
+          <a:bodyPr wrap="square" lIns="73152" tIns="73152" rIns="73152" bIns="73152" anchor="ctr">
             <a:spAutoFit/>
           </a:bodyPr>
           <a:lstStyle/>
@@ -19466,6 +19870,7 @@
           <a:lstStyle/>
           <a:p>
             <a:pPr algn="ctr"/>
+            <a:endParaRPr/>
           </a:p>
         </p:txBody>
       </p:sp>
@@ -19486,7 +19891,7 @@
           <a:noFill/>
         </p:spPr>
         <p:txBody>
-          <a:bodyPr wrap="square" anchor="t" lIns="73152" rIns="73152" tIns="73152" bIns="73152">
+          <a:bodyPr wrap="square" lIns="73152" tIns="73152" rIns="73152" bIns="73152" anchor="t">
             <a:spAutoFit/>
           </a:bodyPr>
           <a:lstStyle/>
@@ -19514,24 +19919,51 @@
           </a:p>
           <a:p>
             <a:pPr algn="l"/>
+            <a:endParaRPr sz="1900" b="0">
+              <a:solidFill>
+                <a:srgbClr val="000000"/>
+              </a:solidFill>
+            </a:endParaRPr>
+          </a:p>
+          <a:p>
+            <a:pPr algn="l"/>
+            <a:r>
+              <a:rPr sz="1900" b="1">
+                <a:solidFill>
+                  <a:srgbClr val="D08F27"/>
+                </a:solidFill>
+              </a:rPr>
+              <a:t>Volatility clustering</a:t>
+            </a:r>
+          </a:p>
+          <a:p>
+            <a:pPr algn="l"/>
             <a:r>
               <a:rPr sz="1900" b="0">
                 <a:solidFill>
                   <a:srgbClr val="000000"/>
                 </a:solidFill>
               </a:rPr>
-              <a:t/>
+              <a:t>Stormy days follow stormy days (Ljung-Box on r²: 890, p &lt; 0.001)</a:t>
             </a:r>
           </a:p>
           <a:p>
             <a:pPr algn="l"/>
+            <a:endParaRPr sz="1900" b="0">
+              <a:solidFill>
+                <a:srgbClr val="000000"/>
+              </a:solidFill>
+            </a:endParaRPr>
+          </a:p>
+          <a:p>
+            <a:pPr algn="l"/>
             <a:r>
               <a:rPr sz="1900" b="1">
                 <a:solidFill>
                   <a:srgbClr val="D08F27"/>
                 </a:solidFill>
               </a:rPr>
-              <a:t>Volatility clustering</a:t>
+              <a:t>Predictable turbulence</a:t>
             </a:r>
           </a:p>
           <a:p>
@@ -19542,52 +19974,16 @@
                   <a:srgbClr val="000000"/>
                 </a:solidFill>
               </a:rPr>
-              <a:t>Stormy days follow stormy days (Ljung-Box on r²: 890, p &lt; 0.001)</a:t>
+              <a:t>Yesterday’s swings predict today’s (ARCH-LM: 393, p &lt; 0.001)</a:t>
             </a:r>
           </a:p>
           <a:p>
             <a:pPr algn="l"/>
-            <a:r>
-              <a:rPr sz="1900" b="0">
-                <a:solidFill>
-                  <a:srgbClr val="000000"/>
-                </a:solidFill>
-              </a:rPr>
-              <a:t/>
-            </a:r>
-          </a:p>
-          <a:p>
-            <a:pPr algn="l"/>
-            <a:r>
-              <a:rPr sz="1900" b="1">
-                <a:solidFill>
-                  <a:srgbClr val="D08F27"/>
-                </a:solidFill>
-              </a:rPr>
-              <a:t>Predictable turbulence</a:t>
-            </a:r>
-          </a:p>
-          <a:p>
-            <a:pPr algn="l"/>
-            <a:r>
-              <a:rPr sz="1900" b="0">
-                <a:solidFill>
-                  <a:srgbClr val="000000"/>
-                </a:solidFill>
-              </a:rPr>
-              <a:t>Yesterday’s swings predict today’s (ARCH-LM: 393, p &lt; 0.001)</a:t>
-            </a:r>
-          </a:p>
-          <a:p>
-            <a:pPr algn="l"/>
-            <a:r>
-              <a:rPr sz="1900" b="0">
-                <a:solidFill>
-                  <a:srgbClr val="000000"/>
-                </a:solidFill>
-              </a:rPr>
-              <a:t/>
-            </a:r>
+            <a:endParaRPr sz="1900" b="0">
+              <a:solidFill>
+                <a:srgbClr val="000000"/>
+              </a:solidFill>
+            </a:endParaRPr>
           </a:p>
           <a:p>
             <a:pPr algn="l"/>
@@ -19654,6 +20050,7 @@
           <a:lstStyle/>
           <a:p>
             <a:pPr algn="ctr"/>
+            <a:endParaRPr/>
           </a:p>
         </p:txBody>
       </p:sp>
@@ -19674,7 +20071,7 @@
           <a:noFill/>
         </p:spPr>
         <p:txBody>
-          <a:bodyPr wrap="square" anchor="ctr" lIns="73152" rIns="73152" tIns="73152" bIns="73152">
+          <a:bodyPr wrap="square" lIns="73152" tIns="73152" rIns="73152" bIns="73152" anchor="ctr">
             <a:spAutoFit/>
           </a:bodyPr>
           <a:lstStyle/>

</xml_diff>